<commit_message>
feat: Update configuration and improve file handling
- Updated `.env.example` to include new environment variables for Cloudflare Tunnel and PPT library cache settings.
- Enhanced `docker-compose.yml` to allow configuration of JWT secret and PPT library path via environment variables.
- Introduced caching mechanism in `generator.ts` to manage PPT library file updates more efficiently.
- Adjusted font size defaults in `generator.py` for better presentation output.
- Added new workspace configuration file for development environment.
- Improved lyrics handling in `FileGenerator.tsx` to manage page breaks more effectively.
</commit_message>
<xml_diff>
--- a/output/敬拜PPT.pptx
+++ b/output/敬拜PPT.pptx
@@ -8,6 +8,37 @@
     <p:sldId id="256" r:id="rId7"/>
     <p:sldId id="257" r:id="rId8"/>
     <p:sldId id="258" r:id="rId9"/>
+    <p:sldId id="259" r:id="rId10"/>
+    <p:sldId id="260" r:id="rId11"/>
+    <p:sldId id="261" r:id="rId12"/>
+    <p:sldId id="262" r:id="rId13"/>
+    <p:sldId id="263" r:id="rId14"/>
+    <p:sldId id="264" r:id="rId15"/>
+    <p:sldId id="265" r:id="rId16"/>
+    <p:sldId id="266" r:id="rId17"/>
+    <p:sldId id="267" r:id="rId18"/>
+    <p:sldId id="268" r:id="rId19"/>
+    <p:sldId id="269" r:id="rId20"/>
+    <p:sldId id="270" r:id="rId21"/>
+    <p:sldId id="271" r:id="rId22"/>
+    <p:sldId id="272" r:id="rId23"/>
+    <p:sldId id="273" r:id="rId24"/>
+    <p:sldId id="274" r:id="rId25"/>
+    <p:sldId id="275" r:id="rId26"/>
+    <p:sldId id="276" r:id="rId27"/>
+    <p:sldId id="277" r:id="rId28"/>
+    <p:sldId id="278" r:id="rId29"/>
+    <p:sldId id="279" r:id="rId30"/>
+    <p:sldId id="280" r:id="rId31"/>
+    <p:sldId id="281" r:id="rId32"/>
+    <p:sldId id="282" r:id="rId33"/>
+    <p:sldId id="283" r:id="rId34"/>
+    <p:sldId id="284" r:id="rId35"/>
+    <p:sldId id="285" r:id="rId36"/>
+    <p:sldId id="286" r:id="rId37"/>
+    <p:sldId id="287" r:id="rId38"/>
+    <p:sldId id="288" r:id="rId39"/>
+    <p:sldId id="289" r:id="rId40"/>
   </p:sldIdLst>
   <p:sldSz cx="9144000" cy="5143500" type="screen4x3"/>
   <p:notesSz cx="6858000" cy="9144000"/>
@@ -3106,8 +3137,53 @@
         </p:nvSpPr>
         <p:spPr>
           <a:xfrm>
-            <a:off x="457200" y="91440"/>
-            <a:ext cx="8229600" cy="2286000"/>
+            <a:off x="228600" y="91440"/>
+            <a:ext cx="8686800" cy="3200400"/>
+          </a:xfrm>
+          <a:prstGeom prst="rect">
+            <a:avLst/>
+          </a:prstGeom>
+          <a:noFill/>
+        </p:spPr>
+        <p:txBody>
+          <a:bodyPr wrap="square">
+            <a:spAutoFit/>
+          </a:bodyPr>
+          <a:lstStyle/>
+          <a:p>
+            <a:pPr algn="ctr"/>
+            <a:r>
+              <a:rPr sz="3200" b="1">
+                <a:solidFill>
+                  <a:srgbClr val="FFFF00"/>
+                </a:solidFill>
+                <a:latin typeface="微軟正黑體"/>
+              </a:rPr>
+              <a:t>1.大聲敬拜全心呼喊 全能的神願祢降臨</a:t>
+            </a:r>
+            <a:br/>
+            <a:r>
+              <a:rPr sz="3200" b="1">
+                <a:solidFill>
+                  <a:srgbClr val="FFFF00"/>
+                </a:solidFill>
+                <a:latin typeface="微軟正黑體"/>
+              </a:rPr>
+              <a:t>慈愛雙手大能膀臂 直到如今仍行神蹟</a:t>
+            </a:r>
+          </a:p>
+        </p:txBody>
+      </p:sp>
+      <p:sp>
+        <p:nvSpPr>
+          <p:cNvPr id="3" name="TextBox 2"/>
+          <p:cNvSpPr txBox="1"/>
+          <p:nvPr/>
+        </p:nvSpPr>
+        <p:spPr>
+          <a:xfrm>
+            <a:off x="228600" y="4572000"/>
+            <a:ext cx="8686800" cy="457200"/>
           </a:xfrm>
           <a:prstGeom prst="rect">
             <a:avLst/>
@@ -3122,13 +3198,74 @@
           <a:p>
             <a:pPr algn="ctr"/>
             <a:r>
+              <a:rPr sz="2000" b="0">
+                <a:solidFill>
+                  <a:srgbClr val="FFFF00"/>
+                </a:solidFill>
+                <a:latin typeface="微軟正黑體"/>
+              </a:rPr>
+              <a:t>《祢眼目必看顧這地》</a:t>
+            </a:r>
+          </a:p>
+        </p:txBody>
+      </p:sp>
+    </p:spTree>
+  </p:cSld>
+  <p:clrMapOvr>
+    <a:masterClrMapping/>
+  </p:clrMapOvr>
+</p:sld>
+</file>
+
+<file path=ppt/slides/slide10.xml><?xml version="1.0" encoding="utf-8"?>
+<p:sld xmlns:a="http://schemas.openxmlformats.org/drawingml/2006/main" xmlns:p="http://schemas.openxmlformats.org/presentationml/2006/main" xmlns:r="http://schemas.openxmlformats.org/officeDocument/2006/relationships">
+  <p:cSld>
+    <p:bg>
+      <p:bgPr>
+        <a:solidFill>
+          <a:srgbClr val="000000"/>
+        </a:solidFill>
+        <a:effectLst/>
+      </p:bgPr>
+    </p:bg>
+    <p:spTree>
+      <p:nvGrpSpPr>
+        <p:cNvPr id="1" name=""/>
+        <p:cNvGrpSpPr/>
+        <p:nvPr/>
+      </p:nvGrpSpPr>
+      <p:grpSpPr/>
+      <p:sp>
+        <p:nvSpPr>
+          <p:cNvPr id="2" name="TextBox 1"/>
+          <p:cNvSpPr txBox="1"/>
+          <p:nvPr/>
+        </p:nvSpPr>
+        <p:spPr>
+          <a:xfrm>
+            <a:off x="228600" y="91440"/>
+            <a:ext cx="8686800" cy="3200400"/>
+          </a:xfrm>
+          <a:prstGeom prst="rect">
+            <a:avLst/>
+          </a:prstGeom>
+          <a:noFill/>
+        </p:spPr>
+        <p:txBody>
+          <a:bodyPr wrap="square">
+            <a:spAutoFit/>
+          </a:bodyPr>
+          <a:lstStyle/>
+          <a:p>
+            <a:pPr algn="ctr"/>
+            <a:r>
               <a:rPr sz="3200" b="1">
                 <a:solidFill>
                   <a:srgbClr val="FFFF00"/>
                 </a:solidFill>
                 <a:latin typeface="微軟正黑體"/>
               </a:rPr>
-              <a:t>從天父而來的愛和恩典 把我們冰冷的心溶解</a:t>
+              <a:t>你是豐盛之主 你是我的牧者 引領我</a:t>
             </a:r>
             <a:br/>
             <a:r>
@@ -3138,7 +3275,7 @@
                 </a:solidFill>
                 <a:latin typeface="微軟正黑體"/>
               </a:rPr>
-              <a:t>讓我們獻出每個音符 把它化為讚美之泉</a:t>
+              <a:t>耶穌我君王 我讚美你 </a:t>
             </a:r>
           </a:p>
         </p:txBody>
@@ -3151,8 +3288,8 @@
         </p:nvSpPr>
         <p:spPr>
           <a:xfrm>
-            <a:off x="457200" y="4663440"/>
-            <a:ext cx="8229600" cy="457200"/>
+            <a:off x="228600" y="4572000"/>
+            <a:ext cx="8686800" cy="457200"/>
           </a:xfrm>
           <a:prstGeom prst="rect">
             <a:avLst/>
@@ -3173,7 +3310,961 @@
                 </a:solidFill>
                 <a:latin typeface="微軟正黑體"/>
               </a:rPr>
-              <a:t>《讚美之泉》</a:t>
+              <a:t>《揚聲歡呼讚美》</a:t>
+            </a:r>
+          </a:p>
+        </p:txBody>
+      </p:sp>
+    </p:spTree>
+  </p:cSld>
+  <p:clrMapOvr>
+    <a:masterClrMapping/>
+  </p:clrMapOvr>
+</p:sld>
+</file>
+
+<file path=ppt/slides/slide11.xml><?xml version="1.0" encoding="utf-8"?>
+<p:sld xmlns:a="http://schemas.openxmlformats.org/drawingml/2006/main" xmlns:p="http://schemas.openxmlformats.org/presentationml/2006/main" xmlns:r="http://schemas.openxmlformats.org/officeDocument/2006/relationships">
+  <p:cSld>
+    <p:bg>
+      <p:bgPr>
+        <a:solidFill>
+          <a:srgbClr val="000000"/>
+        </a:solidFill>
+        <a:effectLst/>
+      </p:bgPr>
+    </p:bg>
+    <p:spTree>
+      <p:nvGrpSpPr>
+        <p:cNvPr id="1" name=""/>
+        <p:cNvGrpSpPr/>
+        <p:nvPr/>
+      </p:nvGrpSpPr>
+      <p:grpSpPr/>
+      <p:sp>
+        <p:nvSpPr>
+          <p:cNvPr id="2" name="TextBox 1"/>
+          <p:cNvSpPr txBox="1"/>
+          <p:nvPr/>
+        </p:nvSpPr>
+        <p:spPr>
+          <a:xfrm>
+            <a:off x="228600" y="91440"/>
+            <a:ext cx="8686800" cy="3200400"/>
+          </a:xfrm>
+          <a:prstGeom prst="rect">
+            <a:avLst/>
+          </a:prstGeom>
+          <a:noFill/>
+        </p:spPr>
+        <p:txBody>
+          <a:bodyPr wrap="square">
+            <a:spAutoFit/>
+          </a:bodyPr>
+          <a:lstStyle/>
+          <a:p>
+            <a:pPr algn="ctr"/>
+            <a:r>
+              <a:rPr sz="3200" b="1">
+                <a:solidFill>
+                  <a:srgbClr val="FFFF00"/>
+                </a:solidFill>
+                <a:latin typeface="微軟正黑體"/>
+              </a:rPr>
+              <a:t>1.要將榮耀能力 歸給耶和華</a:t>
+            </a:r>
+            <a:br/>
+            <a:r>
+              <a:rPr sz="3200" b="1">
+                <a:solidFill>
+                  <a:srgbClr val="FFFF00"/>
+                </a:solidFill>
+                <a:latin typeface="微軟正黑體"/>
+              </a:rPr>
+              <a:t>祂名所當得的 榮耀歸給祂</a:t>
+            </a:r>
+          </a:p>
+        </p:txBody>
+      </p:sp>
+      <p:sp>
+        <p:nvSpPr>
+          <p:cNvPr id="3" name="TextBox 2"/>
+          <p:cNvSpPr txBox="1"/>
+          <p:nvPr/>
+        </p:nvSpPr>
+        <p:spPr>
+          <a:xfrm>
+            <a:off x="228600" y="4572000"/>
+            <a:ext cx="8686800" cy="457200"/>
+          </a:xfrm>
+          <a:prstGeom prst="rect">
+            <a:avLst/>
+          </a:prstGeom>
+          <a:noFill/>
+        </p:spPr>
+        <p:txBody>
+          <a:bodyPr wrap="none">
+            <a:spAutoFit/>
+          </a:bodyPr>
+          <a:lstStyle/>
+          <a:p>
+            <a:pPr algn="ctr"/>
+            <a:r>
+              <a:rPr sz="2000" b="0">
+                <a:solidFill>
+                  <a:srgbClr val="FFFF00"/>
+                </a:solidFill>
+                <a:latin typeface="微軟正黑體"/>
+              </a:rPr>
+              <a:t>《從這代到那代》</a:t>
+            </a:r>
+          </a:p>
+        </p:txBody>
+      </p:sp>
+    </p:spTree>
+  </p:cSld>
+  <p:clrMapOvr>
+    <a:masterClrMapping/>
+  </p:clrMapOvr>
+</p:sld>
+</file>
+
+<file path=ppt/slides/slide12.xml><?xml version="1.0" encoding="utf-8"?>
+<p:sld xmlns:a="http://schemas.openxmlformats.org/drawingml/2006/main" xmlns:p="http://schemas.openxmlformats.org/presentationml/2006/main" xmlns:r="http://schemas.openxmlformats.org/officeDocument/2006/relationships">
+  <p:cSld>
+    <p:bg>
+      <p:bgPr>
+        <a:solidFill>
+          <a:srgbClr val="000000"/>
+        </a:solidFill>
+        <a:effectLst/>
+      </p:bgPr>
+    </p:bg>
+    <p:spTree>
+      <p:nvGrpSpPr>
+        <p:cNvPr id="1" name=""/>
+        <p:cNvGrpSpPr/>
+        <p:nvPr/>
+      </p:nvGrpSpPr>
+      <p:grpSpPr/>
+      <p:sp>
+        <p:nvSpPr>
+          <p:cNvPr id="2" name="TextBox 1"/>
+          <p:cNvSpPr txBox="1"/>
+          <p:nvPr/>
+        </p:nvSpPr>
+        <p:spPr>
+          <a:xfrm>
+            <a:off x="228600" y="91440"/>
+            <a:ext cx="8686800" cy="3200400"/>
+          </a:xfrm>
+          <a:prstGeom prst="rect">
+            <a:avLst/>
+          </a:prstGeom>
+          <a:noFill/>
+        </p:spPr>
+        <p:txBody>
+          <a:bodyPr wrap="square">
+            <a:spAutoFit/>
+          </a:bodyPr>
+          <a:lstStyle/>
+          <a:p>
+            <a:pPr algn="ctr"/>
+            <a:r>
+              <a:rPr sz="3200" b="1">
+                <a:solidFill>
+                  <a:srgbClr val="FFFF00"/>
+                </a:solidFill>
+                <a:latin typeface="微軟正黑體"/>
+              </a:rPr>
+              <a:t>不分種族國家 齊聲來頌揚</a:t>
+            </a:r>
+            <a:br/>
+            <a:r>
+              <a:rPr sz="3200" b="1">
+                <a:solidFill>
+                  <a:srgbClr val="FFFF00"/>
+                </a:solidFill>
+                <a:latin typeface="微軟正黑體"/>
+              </a:rPr>
+              <a:t>在寶座前 高舉雙手</a:t>
+            </a:r>
+          </a:p>
+        </p:txBody>
+      </p:sp>
+      <p:sp>
+        <p:nvSpPr>
+          <p:cNvPr id="3" name="TextBox 2"/>
+          <p:cNvSpPr txBox="1"/>
+          <p:nvPr/>
+        </p:nvSpPr>
+        <p:spPr>
+          <a:xfrm>
+            <a:off x="228600" y="4572000"/>
+            <a:ext cx="8686800" cy="457200"/>
+          </a:xfrm>
+          <a:prstGeom prst="rect">
+            <a:avLst/>
+          </a:prstGeom>
+          <a:noFill/>
+        </p:spPr>
+        <p:txBody>
+          <a:bodyPr wrap="none">
+            <a:spAutoFit/>
+          </a:bodyPr>
+          <a:lstStyle/>
+          <a:p>
+            <a:pPr algn="ctr"/>
+            <a:r>
+              <a:rPr sz="2000" b="0">
+                <a:solidFill>
+                  <a:srgbClr val="FFFF00"/>
+                </a:solidFill>
+                <a:latin typeface="微軟正黑體"/>
+              </a:rPr>
+              <a:t>《從這代到那代》</a:t>
+            </a:r>
+          </a:p>
+        </p:txBody>
+      </p:sp>
+    </p:spTree>
+  </p:cSld>
+  <p:clrMapOvr>
+    <a:masterClrMapping/>
+  </p:clrMapOvr>
+</p:sld>
+</file>
+
+<file path=ppt/slides/slide13.xml><?xml version="1.0" encoding="utf-8"?>
+<p:sld xmlns:a="http://schemas.openxmlformats.org/drawingml/2006/main" xmlns:p="http://schemas.openxmlformats.org/presentationml/2006/main" xmlns:r="http://schemas.openxmlformats.org/officeDocument/2006/relationships">
+  <p:cSld>
+    <p:bg>
+      <p:bgPr>
+        <a:solidFill>
+          <a:srgbClr val="000000"/>
+        </a:solidFill>
+        <a:effectLst/>
+      </p:bgPr>
+    </p:bg>
+    <p:spTree>
+      <p:nvGrpSpPr>
+        <p:cNvPr id="1" name=""/>
+        <p:cNvGrpSpPr/>
+        <p:nvPr/>
+      </p:nvGrpSpPr>
+      <p:grpSpPr/>
+      <p:sp>
+        <p:nvSpPr>
+          <p:cNvPr id="2" name="TextBox 1"/>
+          <p:cNvSpPr txBox="1"/>
+          <p:nvPr/>
+        </p:nvSpPr>
+        <p:spPr>
+          <a:xfrm>
+            <a:off x="228600" y="91440"/>
+            <a:ext cx="8686800" cy="3200400"/>
+          </a:xfrm>
+          <a:prstGeom prst="rect">
+            <a:avLst/>
+          </a:prstGeom>
+          <a:noFill/>
+        </p:spPr>
+        <p:txBody>
+          <a:bodyPr wrap="square">
+            <a:spAutoFit/>
+          </a:bodyPr>
+          <a:lstStyle/>
+          <a:p>
+            <a:pPr algn="ctr"/>
+            <a:r>
+              <a:rPr sz="3200" b="1">
+                <a:solidFill>
+                  <a:srgbClr val="FFFF00"/>
+                </a:solidFill>
+                <a:latin typeface="微軟正黑體"/>
+              </a:rPr>
+              <a:t>※從這代到那代 萬民不停頌讚</a:t>
+            </a:r>
+            <a:br/>
+            <a:r>
+              <a:rPr sz="3200" b="1">
+                <a:solidFill>
+                  <a:srgbClr val="FFFF00"/>
+                </a:solidFill>
+                <a:latin typeface="微軟正黑體"/>
+              </a:rPr>
+              <a:t>從地極到地極 萬民歡然獻祭</a:t>
+            </a:r>
+          </a:p>
+        </p:txBody>
+      </p:sp>
+      <p:sp>
+        <p:nvSpPr>
+          <p:cNvPr id="3" name="TextBox 2"/>
+          <p:cNvSpPr txBox="1"/>
+          <p:nvPr/>
+        </p:nvSpPr>
+        <p:spPr>
+          <a:xfrm>
+            <a:off x="228600" y="4572000"/>
+            <a:ext cx="8686800" cy="457200"/>
+          </a:xfrm>
+          <a:prstGeom prst="rect">
+            <a:avLst/>
+          </a:prstGeom>
+          <a:noFill/>
+        </p:spPr>
+        <p:txBody>
+          <a:bodyPr wrap="none">
+            <a:spAutoFit/>
+          </a:bodyPr>
+          <a:lstStyle/>
+          <a:p>
+            <a:pPr algn="ctr"/>
+            <a:r>
+              <a:rPr sz="2000" b="0">
+                <a:solidFill>
+                  <a:srgbClr val="FFFF00"/>
+                </a:solidFill>
+                <a:latin typeface="微軟正黑體"/>
+              </a:rPr>
+              <a:t>《從這代到那代》</a:t>
+            </a:r>
+          </a:p>
+        </p:txBody>
+      </p:sp>
+    </p:spTree>
+  </p:cSld>
+  <p:clrMapOvr>
+    <a:masterClrMapping/>
+  </p:clrMapOvr>
+</p:sld>
+</file>
+
+<file path=ppt/slides/slide14.xml><?xml version="1.0" encoding="utf-8"?>
+<p:sld xmlns:a="http://schemas.openxmlformats.org/drawingml/2006/main" xmlns:p="http://schemas.openxmlformats.org/presentationml/2006/main" xmlns:r="http://schemas.openxmlformats.org/officeDocument/2006/relationships">
+  <p:cSld>
+    <p:bg>
+      <p:bgPr>
+        <a:solidFill>
+          <a:srgbClr val="000000"/>
+        </a:solidFill>
+        <a:effectLst/>
+      </p:bgPr>
+    </p:bg>
+    <p:spTree>
+      <p:nvGrpSpPr>
+        <p:cNvPr id="1" name=""/>
+        <p:cNvGrpSpPr/>
+        <p:nvPr/>
+      </p:nvGrpSpPr>
+      <p:grpSpPr/>
+      <p:sp>
+        <p:nvSpPr>
+          <p:cNvPr id="2" name="TextBox 1"/>
+          <p:cNvSpPr txBox="1"/>
+          <p:nvPr/>
+        </p:nvSpPr>
+        <p:spPr>
+          <a:xfrm>
+            <a:off x="228600" y="91440"/>
+            <a:ext cx="8686800" cy="3200400"/>
+          </a:xfrm>
+          <a:prstGeom prst="rect">
+            <a:avLst/>
+          </a:prstGeom>
+          <a:noFill/>
+        </p:spPr>
+        <p:txBody>
+          <a:bodyPr wrap="square">
+            <a:spAutoFit/>
+          </a:bodyPr>
+          <a:lstStyle/>
+          <a:p>
+            <a:pPr algn="ctr"/>
+            <a:r>
+              <a:rPr sz="3200" b="1">
+                <a:solidFill>
+                  <a:srgbClr val="FFFF00"/>
+                </a:solidFill>
+                <a:latin typeface="微軟正黑體"/>
+              </a:rPr>
+              <a:t>從列國到列邦 齊尊崇祢為王</a:t>
+            </a:r>
+            <a:br/>
+            <a:r>
+              <a:rPr sz="3200" b="1">
+                <a:solidFill>
+                  <a:srgbClr val="FFFF00"/>
+                </a:solidFill>
+                <a:latin typeface="微軟正黑體"/>
+              </a:rPr>
+              <a:t>高唱哈利路亞 齊敬拜彌賽亞</a:t>
+            </a:r>
+          </a:p>
+        </p:txBody>
+      </p:sp>
+      <p:sp>
+        <p:nvSpPr>
+          <p:cNvPr id="3" name="TextBox 2"/>
+          <p:cNvSpPr txBox="1"/>
+          <p:nvPr/>
+        </p:nvSpPr>
+        <p:spPr>
+          <a:xfrm>
+            <a:off x="228600" y="4572000"/>
+            <a:ext cx="8686800" cy="457200"/>
+          </a:xfrm>
+          <a:prstGeom prst="rect">
+            <a:avLst/>
+          </a:prstGeom>
+          <a:noFill/>
+        </p:spPr>
+        <p:txBody>
+          <a:bodyPr wrap="none">
+            <a:spAutoFit/>
+          </a:bodyPr>
+          <a:lstStyle/>
+          <a:p>
+            <a:pPr algn="ctr"/>
+            <a:r>
+              <a:rPr sz="2000" b="0">
+                <a:solidFill>
+                  <a:srgbClr val="FFFF00"/>
+                </a:solidFill>
+                <a:latin typeface="微軟正黑體"/>
+              </a:rPr>
+              <a:t>《從這代到那代》</a:t>
+            </a:r>
+          </a:p>
+        </p:txBody>
+      </p:sp>
+    </p:spTree>
+  </p:cSld>
+  <p:clrMapOvr>
+    <a:masterClrMapping/>
+  </p:clrMapOvr>
+</p:sld>
+</file>
+
+<file path=ppt/slides/slide15.xml><?xml version="1.0" encoding="utf-8"?>
+<p:sld xmlns:a="http://schemas.openxmlformats.org/drawingml/2006/main" xmlns:p="http://schemas.openxmlformats.org/presentationml/2006/main" xmlns:r="http://schemas.openxmlformats.org/officeDocument/2006/relationships">
+  <p:cSld>
+    <p:bg>
+      <p:bgPr>
+        <a:solidFill>
+          <a:srgbClr val="000000"/>
+        </a:solidFill>
+        <a:effectLst/>
+      </p:bgPr>
+    </p:bg>
+    <p:spTree>
+      <p:nvGrpSpPr>
+        <p:cNvPr id="1" name=""/>
+        <p:cNvGrpSpPr/>
+        <p:nvPr/>
+      </p:nvGrpSpPr>
+      <p:grpSpPr/>
+      <p:sp>
+        <p:nvSpPr>
+          <p:cNvPr id="2" name="TextBox 1"/>
+          <p:cNvSpPr txBox="1"/>
+          <p:nvPr/>
+        </p:nvSpPr>
+        <p:spPr>
+          <a:xfrm>
+            <a:off x="228600" y="91440"/>
+            <a:ext cx="8686800" cy="3200400"/>
+          </a:xfrm>
+          <a:prstGeom prst="rect">
+            <a:avLst/>
+          </a:prstGeom>
+          <a:noFill/>
+        </p:spPr>
+        <p:txBody>
+          <a:bodyPr wrap="square">
+            <a:spAutoFit/>
+          </a:bodyPr>
+          <a:lstStyle/>
+          <a:p>
+            <a:pPr algn="ctr"/>
+            <a:r>
+              <a:rPr sz="3200" b="1">
+                <a:solidFill>
+                  <a:srgbClr val="FFFF00"/>
+                </a:solidFill>
+                <a:latin typeface="微軟正黑體"/>
+              </a:rPr>
+              <a:t>§ 眾城門 抬起頭 榮耀君王將要進來</a:t>
+            </a:r>
+            <a:br/>
+            <a:r>
+              <a:rPr sz="3200" b="1">
+                <a:solidFill>
+                  <a:srgbClr val="FFFF00"/>
+                </a:solidFill>
+                <a:latin typeface="微軟正黑體"/>
+              </a:rPr>
+              <a:t>末後的榮耀大過先前的</a:t>
+            </a:r>
+          </a:p>
+        </p:txBody>
+      </p:sp>
+      <p:sp>
+        <p:nvSpPr>
+          <p:cNvPr id="3" name="TextBox 2"/>
+          <p:cNvSpPr txBox="1"/>
+          <p:nvPr/>
+        </p:nvSpPr>
+        <p:spPr>
+          <a:xfrm>
+            <a:off x="228600" y="4572000"/>
+            <a:ext cx="8686800" cy="457200"/>
+          </a:xfrm>
+          <a:prstGeom prst="rect">
+            <a:avLst/>
+          </a:prstGeom>
+          <a:noFill/>
+        </p:spPr>
+        <p:txBody>
+          <a:bodyPr wrap="none">
+            <a:spAutoFit/>
+          </a:bodyPr>
+          <a:lstStyle/>
+          <a:p>
+            <a:pPr algn="ctr"/>
+            <a:r>
+              <a:rPr sz="2000" b="0">
+                <a:solidFill>
+                  <a:srgbClr val="FFFF00"/>
+                </a:solidFill>
+                <a:latin typeface="微軟正黑體"/>
+              </a:rPr>
+              <a:t>《從這代到那代》</a:t>
+            </a:r>
+          </a:p>
+        </p:txBody>
+      </p:sp>
+    </p:spTree>
+  </p:cSld>
+  <p:clrMapOvr>
+    <a:masterClrMapping/>
+  </p:clrMapOvr>
+</p:sld>
+</file>
+
+<file path=ppt/slides/slide16.xml><?xml version="1.0" encoding="utf-8"?>
+<p:sld xmlns:a="http://schemas.openxmlformats.org/drawingml/2006/main" xmlns:p="http://schemas.openxmlformats.org/presentationml/2006/main" xmlns:r="http://schemas.openxmlformats.org/officeDocument/2006/relationships">
+  <p:cSld>
+    <p:bg>
+      <p:bgPr>
+        <a:solidFill>
+          <a:srgbClr val="000000"/>
+        </a:solidFill>
+        <a:effectLst/>
+      </p:bgPr>
+    </p:bg>
+    <p:spTree>
+      <p:nvGrpSpPr>
+        <p:cNvPr id="1" name=""/>
+        <p:cNvGrpSpPr/>
+        <p:nvPr/>
+      </p:nvGrpSpPr>
+      <p:grpSpPr/>
+      <p:sp>
+        <p:nvSpPr>
+          <p:cNvPr id="2" name="TextBox 1"/>
+          <p:cNvSpPr txBox="1"/>
+          <p:nvPr/>
+        </p:nvSpPr>
+        <p:spPr>
+          <a:xfrm>
+            <a:off x="228600" y="91440"/>
+            <a:ext cx="8686800" cy="3200400"/>
+          </a:xfrm>
+          <a:prstGeom prst="rect">
+            <a:avLst/>
+          </a:prstGeom>
+          <a:noFill/>
+        </p:spPr>
+        <p:txBody>
+          <a:bodyPr wrap="square">
+            <a:spAutoFit/>
+          </a:bodyPr>
+          <a:lstStyle/>
+          <a:p>
+            <a:pPr algn="ctr"/>
+            <a:r>
+              <a:rPr sz="3200" b="1">
+                <a:solidFill>
+                  <a:srgbClr val="FFFF00"/>
+                </a:solidFill>
+                <a:latin typeface="微軟正黑體"/>
+              </a:rPr>
+              <a:t>眾城門 抬起頭 榮耀君王將要進來</a:t>
+            </a:r>
+            <a:br/>
+            <a:r>
+              <a:rPr sz="3200" b="1">
+                <a:solidFill>
+                  <a:srgbClr val="FFFF00"/>
+                </a:solidFill>
+                <a:latin typeface="微軟正黑體"/>
+              </a:rPr>
+              <a:t>萬國敬拜如眾水的聲音</a:t>
+            </a:r>
+          </a:p>
+        </p:txBody>
+      </p:sp>
+      <p:sp>
+        <p:nvSpPr>
+          <p:cNvPr id="3" name="TextBox 2"/>
+          <p:cNvSpPr txBox="1"/>
+          <p:nvPr/>
+        </p:nvSpPr>
+        <p:spPr>
+          <a:xfrm>
+            <a:off x="228600" y="4572000"/>
+            <a:ext cx="8686800" cy="457200"/>
+          </a:xfrm>
+          <a:prstGeom prst="rect">
+            <a:avLst/>
+          </a:prstGeom>
+          <a:noFill/>
+        </p:spPr>
+        <p:txBody>
+          <a:bodyPr wrap="none">
+            <a:spAutoFit/>
+          </a:bodyPr>
+          <a:lstStyle/>
+          <a:p>
+            <a:pPr algn="ctr"/>
+            <a:r>
+              <a:rPr sz="2000" b="0">
+                <a:solidFill>
+                  <a:srgbClr val="FFFF00"/>
+                </a:solidFill>
+                <a:latin typeface="微軟正黑體"/>
+              </a:rPr>
+              <a:t>《從這代到那代》</a:t>
+            </a:r>
+          </a:p>
+        </p:txBody>
+      </p:sp>
+    </p:spTree>
+  </p:cSld>
+  <p:clrMapOvr>
+    <a:masterClrMapping/>
+  </p:clrMapOvr>
+</p:sld>
+</file>
+
+<file path=ppt/slides/slide17.xml><?xml version="1.0" encoding="utf-8"?>
+<p:sld xmlns:a="http://schemas.openxmlformats.org/drawingml/2006/main" xmlns:p="http://schemas.openxmlformats.org/presentationml/2006/main" xmlns:r="http://schemas.openxmlformats.org/officeDocument/2006/relationships">
+  <p:cSld>
+    <p:bg>
+      <p:bgPr>
+        <a:solidFill>
+          <a:srgbClr val="000000"/>
+        </a:solidFill>
+        <a:effectLst/>
+      </p:bgPr>
+    </p:bg>
+    <p:spTree>
+      <p:nvGrpSpPr>
+        <p:cNvPr id="1" name=""/>
+        <p:cNvGrpSpPr/>
+        <p:nvPr/>
+      </p:nvGrpSpPr>
+      <p:grpSpPr/>
+      <p:sp>
+        <p:nvSpPr>
+          <p:cNvPr id="2" name="TextBox 1"/>
+          <p:cNvSpPr txBox="1"/>
+          <p:nvPr/>
+        </p:nvSpPr>
+        <p:spPr>
+          <a:xfrm>
+            <a:off x="228600" y="91440"/>
+            <a:ext cx="8686800" cy="3200400"/>
+          </a:xfrm>
+          <a:prstGeom prst="rect">
+            <a:avLst/>
+          </a:prstGeom>
+          <a:noFill/>
+        </p:spPr>
+        <p:txBody>
+          <a:bodyPr wrap="square">
+            <a:spAutoFit/>
+          </a:bodyPr>
+          <a:lstStyle/>
+          <a:p>
+            <a:pPr algn="ctr"/>
+            <a:r>
+              <a:rPr sz="3200" b="1">
+                <a:solidFill>
+                  <a:srgbClr val="FFFF00"/>
+                </a:solidFill>
+                <a:latin typeface="微軟正黑體"/>
+              </a:rPr>
+              <a:t>1.我們等候主 不住尋求祢面</a:t>
+            </a:r>
+            <a:br/>
+            <a:r>
+              <a:rPr sz="3200" b="1">
+                <a:solidFill>
+                  <a:srgbClr val="FFFF00"/>
+                </a:solidFill>
+                <a:latin typeface="微軟正黑體"/>
+              </a:rPr>
+              <a:t>晝夜地禱告 為這世代呼求</a:t>
+            </a:r>
+          </a:p>
+        </p:txBody>
+      </p:sp>
+      <p:sp>
+        <p:nvSpPr>
+          <p:cNvPr id="3" name="TextBox 2"/>
+          <p:cNvSpPr txBox="1"/>
+          <p:nvPr/>
+        </p:nvSpPr>
+        <p:spPr>
+          <a:xfrm>
+            <a:off x="228600" y="4572000"/>
+            <a:ext cx="8686800" cy="457200"/>
+          </a:xfrm>
+          <a:prstGeom prst="rect">
+            <a:avLst/>
+          </a:prstGeom>
+          <a:noFill/>
+        </p:spPr>
+        <p:txBody>
+          <a:bodyPr wrap="none">
+            <a:spAutoFit/>
+          </a:bodyPr>
+          <a:lstStyle/>
+          <a:p>
+            <a:pPr algn="ctr"/>
+            <a:r>
+              <a:rPr sz="2000" b="0">
+                <a:solidFill>
+                  <a:srgbClr val="FFFF00"/>
+                </a:solidFill>
+                <a:latin typeface="微軟正黑體"/>
+              </a:rPr>
+              <a:t>《我渴望看見》</a:t>
+            </a:r>
+          </a:p>
+        </p:txBody>
+      </p:sp>
+    </p:spTree>
+  </p:cSld>
+  <p:clrMapOvr>
+    <a:masterClrMapping/>
+  </p:clrMapOvr>
+</p:sld>
+</file>
+
+<file path=ppt/slides/slide18.xml><?xml version="1.0" encoding="utf-8"?>
+<p:sld xmlns:a="http://schemas.openxmlformats.org/drawingml/2006/main" xmlns:p="http://schemas.openxmlformats.org/presentationml/2006/main" xmlns:r="http://schemas.openxmlformats.org/officeDocument/2006/relationships">
+  <p:cSld>
+    <p:bg>
+      <p:bgPr>
+        <a:solidFill>
+          <a:srgbClr val="000000"/>
+        </a:solidFill>
+        <a:effectLst/>
+      </p:bgPr>
+    </p:bg>
+    <p:spTree>
+      <p:nvGrpSpPr>
+        <p:cNvPr id="1" name=""/>
+        <p:cNvGrpSpPr/>
+        <p:nvPr/>
+      </p:nvGrpSpPr>
+      <p:grpSpPr/>
+      <p:sp>
+        <p:nvSpPr>
+          <p:cNvPr id="2" name="TextBox 1"/>
+          <p:cNvSpPr txBox="1"/>
+          <p:nvPr/>
+        </p:nvSpPr>
+        <p:spPr>
+          <a:xfrm>
+            <a:off x="228600" y="91440"/>
+            <a:ext cx="8686800" cy="3200400"/>
+          </a:xfrm>
+          <a:prstGeom prst="rect">
+            <a:avLst/>
+          </a:prstGeom>
+          <a:noFill/>
+        </p:spPr>
+        <p:txBody>
+          <a:bodyPr wrap="square">
+            <a:spAutoFit/>
+          </a:bodyPr>
+          <a:lstStyle/>
+          <a:p>
+            <a:pPr algn="ctr"/>
+            <a:r>
+              <a:rPr sz="3200" b="1">
+                <a:solidFill>
+                  <a:srgbClr val="FFFF00"/>
+                </a:solidFill>
+                <a:latin typeface="微軟正黑體"/>
+              </a:rPr>
+              <a:t>側耳來垂聽 謙卑悔改聲音</a:t>
+            </a:r>
+            <a:br/>
+            <a:r>
+              <a:rPr sz="3200" b="1">
+                <a:solidFill>
+                  <a:srgbClr val="FFFF00"/>
+                </a:solidFill>
+                <a:latin typeface="微軟正黑體"/>
+              </a:rPr>
+              <a:t>願救贖和醫治臨到這地</a:t>
+            </a:r>
+          </a:p>
+        </p:txBody>
+      </p:sp>
+      <p:sp>
+        <p:nvSpPr>
+          <p:cNvPr id="3" name="TextBox 2"/>
+          <p:cNvSpPr txBox="1"/>
+          <p:nvPr/>
+        </p:nvSpPr>
+        <p:spPr>
+          <a:xfrm>
+            <a:off x="228600" y="4572000"/>
+            <a:ext cx="8686800" cy="457200"/>
+          </a:xfrm>
+          <a:prstGeom prst="rect">
+            <a:avLst/>
+          </a:prstGeom>
+          <a:noFill/>
+        </p:spPr>
+        <p:txBody>
+          <a:bodyPr wrap="none">
+            <a:spAutoFit/>
+          </a:bodyPr>
+          <a:lstStyle/>
+          <a:p>
+            <a:pPr algn="ctr"/>
+            <a:r>
+              <a:rPr sz="2000" b="0">
+                <a:solidFill>
+                  <a:srgbClr val="FFFF00"/>
+                </a:solidFill>
+                <a:latin typeface="微軟正黑體"/>
+              </a:rPr>
+              <a:t>《我渴望看見》</a:t>
+            </a:r>
+          </a:p>
+        </p:txBody>
+      </p:sp>
+    </p:spTree>
+  </p:cSld>
+  <p:clrMapOvr>
+    <a:masterClrMapping/>
+  </p:clrMapOvr>
+</p:sld>
+</file>
+
+<file path=ppt/slides/slide19.xml><?xml version="1.0" encoding="utf-8"?>
+<p:sld xmlns:a="http://schemas.openxmlformats.org/drawingml/2006/main" xmlns:p="http://schemas.openxmlformats.org/presentationml/2006/main" xmlns:r="http://schemas.openxmlformats.org/officeDocument/2006/relationships">
+  <p:cSld>
+    <p:bg>
+      <p:bgPr>
+        <a:solidFill>
+          <a:srgbClr val="000000"/>
+        </a:solidFill>
+        <a:effectLst/>
+      </p:bgPr>
+    </p:bg>
+    <p:spTree>
+      <p:nvGrpSpPr>
+        <p:cNvPr id="1" name=""/>
+        <p:cNvGrpSpPr/>
+        <p:nvPr/>
+      </p:nvGrpSpPr>
+      <p:grpSpPr/>
+      <p:sp>
+        <p:nvSpPr>
+          <p:cNvPr id="2" name="TextBox 1"/>
+          <p:cNvSpPr txBox="1"/>
+          <p:nvPr/>
+        </p:nvSpPr>
+        <p:spPr>
+          <a:xfrm>
+            <a:off x="228600" y="91440"/>
+            <a:ext cx="8686800" cy="3200400"/>
+          </a:xfrm>
+          <a:prstGeom prst="rect">
+            <a:avLst/>
+          </a:prstGeom>
+          <a:noFill/>
+        </p:spPr>
+        <p:txBody>
+          <a:bodyPr wrap="square">
+            <a:spAutoFit/>
+          </a:bodyPr>
+          <a:lstStyle/>
+          <a:p>
+            <a:pPr algn="ctr"/>
+            <a:r>
+              <a:rPr sz="3200" b="1">
+                <a:solidFill>
+                  <a:srgbClr val="FFFF00"/>
+                </a:solidFill>
+                <a:latin typeface="微軟正黑體"/>
+              </a:rPr>
+              <a:t>※我渴望看見祢的榮耀彰顯</a:t>
+            </a:r>
+            <a:br/>
+            <a:r>
+              <a:rPr sz="3200" b="1">
+                <a:solidFill>
+                  <a:srgbClr val="FFFF00"/>
+                </a:solidFill>
+                <a:latin typeface="微軟正黑體"/>
+              </a:rPr>
+              <a:t>像雲彩圍繞充滿在這地</a:t>
+            </a:r>
+          </a:p>
+        </p:txBody>
+      </p:sp>
+      <p:sp>
+        <p:nvSpPr>
+          <p:cNvPr id="3" name="TextBox 2"/>
+          <p:cNvSpPr txBox="1"/>
+          <p:nvPr/>
+        </p:nvSpPr>
+        <p:spPr>
+          <a:xfrm>
+            <a:off x="228600" y="4572000"/>
+            <a:ext cx="8686800" cy="457200"/>
+          </a:xfrm>
+          <a:prstGeom prst="rect">
+            <a:avLst/>
+          </a:prstGeom>
+          <a:noFill/>
+        </p:spPr>
+        <p:txBody>
+          <a:bodyPr wrap="none">
+            <a:spAutoFit/>
+          </a:bodyPr>
+          <a:lstStyle/>
+          <a:p>
+            <a:pPr algn="ctr"/>
+            <a:r>
+              <a:rPr sz="2000" b="0">
+                <a:solidFill>
+                  <a:srgbClr val="FFFF00"/>
+                </a:solidFill>
+                <a:latin typeface="微軟正黑體"/>
+              </a:rPr>
+              <a:t>《我渴望看見》</a:t>
             </a:r>
           </a:p>
         </p:txBody>
@@ -3212,8 +4303,53 @@
         </p:nvSpPr>
         <p:spPr>
           <a:xfrm>
-            <a:off x="457200" y="91440"/>
-            <a:ext cx="8229600" cy="2286000"/>
+            <a:off x="228600" y="91440"/>
+            <a:ext cx="8686800" cy="3200400"/>
+          </a:xfrm>
+          <a:prstGeom prst="rect">
+            <a:avLst/>
+          </a:prstGeom>
+          <a:noFill/>
+        </p:spPr>
+        <p:txBody>
+          <a:bodyPr wrap="square">
+            <a:spAutoFit/>
+          </a:bodyPr>
+          <a:lstStyle/>
+          <a:p>
+            <a:pPr algn="ctr"/>
+            <a:r>
+              <a:rPr sz="3200" b="1">
+                <a:solidFill>
+                  <a:srgbClr val="FFFF00"/>
+                </a:solidFill>
+                <a:latin typeface="微軟正黑體"/>
+              </a:rPr>
+              <a:t>2.敬拜聲音充滿全地 高舉雙手榮耀歸祢</a:t>
+            </a:r>
+            <a:br/>
+            <a:r>
+              <a:rPr sz="3200" b="1">
+                <a:solidFill>
+                  <a:srgbClr val="FFFF00"/>
+                </a:solidFill>
+                <a:latin typeface="微軟正黑體"/>
+              </a:rPr>
+              <a:t>專心謹守祢的話語 世世代代都不偏離</a:t>
+            </a:r>
+          </a:p>
+        </p:txBody>
+      </p:sp>
+      <p:sp>
+        <p:nvSpPr>
+          <p:cNvPr id="3" name="TextBox 2"/>
+          <p:cNvSpPr txBox="1"/>
+          <p:nvPr/>
+        </p:nvSpPr>
+        <p:spPr>
+          <a:xfrm>
+            <a:off x="228600" y="4572000"/>
+            <a:ext cx="8686800" cy="457200"/>
           </a:xfrm>
           <a:prstGeom prst="rect">
             <a:avLst/>
@@ -3228,13 +4364,74 @@
           <a:p>
             <a:pPr algn="ctr"/>
             <a:r>
+              <a:rPr sz="2000" b="0">
+                <a:solidFill>
+                  <a:srgbClr val="FFFF00"/>
+                </a:solidFill>
+                <a:latin typeface="微軟正黑體"/>
+              </a:rPr>
+              <a:t>《祢眼目必看顧這地》</a:t>
+            </a:r>
+          </a:p>
+        </p:txBody>
+      </p:sp>
+    </p:spTree>
+  </p:cSld>
+  <p:clrMapOvr>
+    <a:masterClrMapping/>
+  </p:clrMapOvr>
+</p:sld>
+</file>
+
+<file path=ppt/slides/slide20.xml><?xml version="1.0" encoding="utf-8"?>
+<p:sld xmlns:a="http://schemas.openxmlformats.org/drawingml/2006/main" xmlns:p="http://schemas.openxmlformats.org/presentationml/2006/main" xmlns:r="http://schemas.openxmlformats.org/officeDocument/2006/relationships">
+  <p:cSld>
+    <p:bg>
+      <p:bgPr>
+        <a:solidFill>
+          <a:srgbClr val="000000"/>
+        </a:solidFill>
+        <a:effectLst/>
+      </p:bgPr>
+    </p:bg>
+    <p:spTree>
+      <p:nvGrpSpPr>
+        <p:cNvPr id="1" name=""/>
+        <p:cNvGrpSpPr/>
+        <p:nvPr/>
+      </p:nvGrpSpPr>
+      <p:grpSpPr/>
+      <p:sp>
+        <p:nvSpPr>
+          <p:cNvPr id="2" name="TextBox 1"/>
+          <p:cNvSpPr txBox="1"/>
+          <p:nvPr/>
+        </p:nvSpPr>
+        <p:spPr>
+          <a:xfrm>
+            <a:off x="228600" y="91440"/>
+            <a:ext cx="8686800" cy="3200400"/>
+          </a:xfrm>
+          <a:prstGeom prst="rect">
+            <a:avLst/>
+          </a:prstGeom>
+          <a:noFill/>
+        </p:spPr>
+        <p:txBody>
+          <a:bodyPr wrap="square">
+            <a:spAutoFit/>
+          </a:bodyPr>
+          <a:lstStyle/>
+          <a:p>
+            <a:pPr algn="ctr"/>
+            <a:r>
               <a:rPr sz="3200" b="1">
                 <a:solidFill>
                   <a:srgbClr val="FFFF00"/>
                 </a:solidFill>
                 <a:latin typeface="微軟正黑體"/>
               </a:rPr>
-              <a:t>※ 我們張開口、舉起手 向永生之主稱謝</a:t>
+              <a:t>聖靈如風地吹進每顆枯乾的心靈</a:t>
             </a:r>
             <a:br/>
             <a:r>
@@ -3244,7 +4441,7 @@
                 </a:solidFill>
                 <a:latin typeface="微軟正黑體"/>
               </a:rPr>
-              <a:t>使讚美之泉 流入每個人的心間 </a:t>
+              <a:t>我們靈魂再次地甦醒</a:t>
             </a:r>
           </a:p>
         </p:txBody>
@@ -3257,8 +4454,8 @@
         </p:nvSpPr>
         <p:spPr>
           <a:xfrm>
-            <a:off x="457200" y="4663440"/>
-            <a:ext cx="8229600" cy="457200"/>
+            <a:off x="228600" y="4572000"/>
+            <a:ext cx="8686800" cy="457200"/>
           </a:xfrm>
           <a:prstGeom prst="rect">
             <a:avLst/>
@@ -3279,7 +4476,961 @@
                 </a:solidFill>
                 <a:latin typeface="微軟正黑體"/>
               </a:rPr>
-              <a:t>《讚美之泉》</a:t>
+              <a:t>《我渴望看見》</a:t>
+            </a:r>
+          </a:p>
+        </p:txBody>
+      </p:sp>
+    </p:spTree>
+  </p:cSld>
+  <p:clrMapOvr>
+    <a:masterClrMapping/>
+  </p:clrMapOvr>
+</p:sld>
+</file>
+
+<file path=ppt/slides/slide21.xml><?xml version="1.0" encoding="utf-8"?>
+<p:sld xmlns:a="http://schemas.openxmlformats.org/drawingml/2006/main" xmlns:p="http://schemas.openxmlformats.org/presentationml/2006/main" xmlns:r="http://schemas.openxmlformats.org/officeDocument/2006/relationships">
+  <p:cSld>
+    <p:bg>
+      <p:bgPr>
+        <a:solidFill>
+          <a:srgbClr val="000000"/>
+        </a:solidFill>
+        <a:effectLst/>
+      </p:bgPr>
+    </p:bg>
+    <p:spTree>
+      <p:nvGrpSpPr>
+        <p:cNvPr id="1" name=""/>
+        <p:cNvGrpSpPr/>
+        <p:nvPr/>
+      </p:nvGrpSpPr>
+      <p:grpSpPr/>
+      <p:sp>
+        <p:nvSpPr>
+          <p:cNvPr id="2" name="TextBox 1"/>
+          <p:cNvSpPr txBox="1"/>
+          <p:nvPr/>
+        </p:nvSpPr>
+        <p:spPr>
+          <a:xfrm>
+            <a:off x="228600" y="91440"/>
+            <a:ext cx="8686800" cy="3200400"/>
+          </a:xfrm>
+          <a:prstGeom prst="rect">
+            <a:avLst/>
+          </a:prstGeom>
+          <a:noFill/>
+        </p:spPr>
+        <p:txBody>
+          <a:bodyPr wrap="square">
+            <a:spAutoFit/>
+          </a:bodyPr>
+          <a:lstStyle/>
+          <a:p>
+            <a:pPr algn="ctr"/>
+            <a:r>
+              <a:rPr sz="3200" b="1">
+                <a:solidFill>
+                  <a:srgbClr val="FFFF00"/>
+                </a:solidFill>
+                <a:latin typeface="微軟正黑體"/>
+              </a:rPr>
+              <a:t>我渴望看見祢的榮耀彰顯</a:t>
+            </a:r>
+            <a:br/>
+            <a:r>
+              <a:rPr sz="3200" b="1">
+                <a:solidFill>
+                  <a:srgbClr val="FFFF00"/>
+                </a:solidFill>
+                <a:latin typeface="微軟正黑體"/>
+              </a:rPr>
+              <a:t>禱告的聲音如水不停息</a:t>
+            </a:r>
+          </a:p>
+        </p:txBody>
+      </p:sp>
+      <p:sp>
+        <p:nvSpPr>
+          <p:cNvPr id="3" name="TextBox 2"/>
+          <p:cNvSpPr txBox="1"/>
+          <p:nvPr/>
+        </p:nvSpPr>
+        <p:spPr>
+          <a:xfrm>
+            <a:off x="228600" y="4572000"/>
+            <a:ext cx="8686800" cy="457200"/>
+          </a:xfrm>
+          <a:prstGeom prst="rect">
+            <a:avLst/>
+          </a:prstGeom>
+          <a:noFill/>
+        </p:spPr>
+        <p:txBody>
+          <a:bodyPr wrap="none">
+            <a:spAutoFit/>
+          </a:bodyPr>
+          <a:lstStyle/>
+          <a:p>
+            <a:pPr algn="ctr"/>
+            <a:r>
+              <a:rPr sz="2000" b="0">
+                <a:solidFill>
+                  <a:srgbClr val="FFFF00"/>
+                </a:solidFill>
+                <a:latin typeface="微軟正黑體"/>
+              </a:rPr>
+              <a:t>《我渴望看見》</a:t>
+            </a:r>
+          </a:p>
+        </p:txBody>
+      </p:sp>
+    </p:spTree>
+  </p:cSld>
+  <p:clrMapOvr>
+    <a:masterClrMapping/>
+  </p:clrMapOvr>
+</p:sld>
+</file>
+
+<file path=ppt/slides/slide22.xml><?xml version="1.0" encoding="utf-8"?>
+<p:sld xmlns:a="http://schemas.openxmlformats.org/drawingml/2006/main" xmlns:p="http://schemas.openxmlformats.org/presentationml/2006/main" xmlns:r="http://schemas.openxmlformats.org/officeDocument/2006/relationships">
+  <p:cSld>
+    <p:bg>
+      <p:bgPr>
+        <a:solidFill>
+          <a:srgbClr val="000000"/>
+        </a:solidFill>
+        <a:effectLst/>
+      </p:bgPr>
+    </p:bg>
+    <p:spTree>
+      <p:nvGrpSpPr>
+        <p:cNvPr id="1" name=""/>
+        <p:cNvGrpSpPr/>
+        <p:nvPr/>
+      </p:nvGrpSpPr>
+      <p:grpSpPr/>
+      <p:sp>
+        <p:nvSpPr>
+          <p:cNvPr id="2" name="TextBox 1"/>
+          <p:cNvSpPr txBox="1"/>
+          <p:nvPr/>
+        </p:nvSpPr>
+        <p:spPr>
+          <a:xfrm>
+            <a:off x="228600" y="91440"/>
+            <a:ext cx="8686800" cy="3200400"/>
+          </a:xfrm>
+          <a:prstGeom prst="rect">
+            <a:avLst/>
+          </a:prstGeom>
+          <a:noFill/>
+        </p:spPr>
+        <p:txBody>
+          <a:bodyPr wrap="square">
+            <a:spAutoFit/>
+          </a:bodyPr>
+          <a:lstStyle/>
+          <a:p>
+            <a:pPr algn="ctr"/>
+            <a:r>
+              <a:rPr sz="3200" b="1">
+                <a:solidFill>
+                  <a:srgbClr val="FFFF00"/>
+                </a:solidFill>
+                <a:latin typeface="微軟正黑體"/>
+              </a:rPr>
+              <a:t>父親回轉向兒女 兒女回轉向父親</a:t>
+            </a:r>
+            <a:br/>
+            <a:r>
+              <a:rPr sz="3200" b="1">
+                <a:solidFill>
+                  <a:srgbClr val="FFFF00"/>
+                </a:solidFill>
+                <a:latin typeface="微軟正黑體"/>
+              </a:rPr>
+              <a:t>每個世代合一敬拜祢</a:t>
+            </a:r>
+          </a:p>
+        </p:txBody>
+      </p:sp>
+      <p:sp>
+        <p:nvSpPr>
+          <p:cNvPr id="3" name="TextBox 2"/>
+          <p:cNvSpPr txBox="1"/>
+          <p:nvPr/>
+        </p:nvSpPr>
+        <p:spPr>
+          <a:xfrm>
+            <a:off x="228600" y="4572000"/>
+            <a:ext cx="8686800" cy="457200"/>
+          </a:xfrm>
+          <a:prstGeom prst="rect">
+            <a:avLst/>
+          </a:prstGeom>
+          <a:noFill/>
+        </p:spPr>
+        <p:txBody>
+          <a:bodyPr wrap="none">
+            <a:spAutoFit/>
+          </a:bodyPr>
+          <a:lstStyle/>
+          <a:p>
+            <a:pPr algn="ctr"/>
+            <a:r>
+              <a:rPr sz="2000" b="0">
+                <a:solidFill>
+                  <a:srgbClr val="FFFF00"/>
+                </a:solidFill>
+                <a:latin typeface="微軟正黑體"/>
+              </a:rPr>
+              <a:t>《我渴望看見》</a:t>
+            </a:r>
+          </a:p>
+        </p:txBody>
+      </p:sp>
+    </p:spTree>
+  </p:cSld>
+  <p:clrMapOvr>
+    <a:masterClrMapping/>
+  </p:clrMapOvr>
+</p:sld>
+</file>
+
+<file path=ppt/slides/slide23.xml><?xml version="1.0" encoding="utf-8"?>
+<p:sld xmlns:a="http://schemas.openxmlformats.org/drawingml/2006/main" xmlns:p="http://schemas.openxmlformats.org/presentationml/2006/main" xmlns:r="http://schemas.openxmlformats.org/officeDocument/2006/relationships">
+  <p:cSld>
+    <p:bg>
+      <p:bgPr>
+        <a:solidFill>
+          <a:srgbClr val="000000"/>
+        </a:solidFill>
+        <a:effectLst/>
+      </p:bgPr>
+    </p:bg>
+    <p:spTree>
+      <p:nvGrpSpPr>
+        <p:cNvPr id="1" name=""/>
+        <p:cNvGrpSpPr/>
+        <p:nvPr/>
+      </p:nvGrpSpPr>
+      <p:grpSpPr/>
+      <p:sp>
+        <p:nvSpPr>
+          <p:cNvPr id="2" name="TextBox 1"/>
+          <p:cNvSpPr txBox="1"/>
+          <p:nvPr/>
+        </p:nvSpPr>
+        <p:spPr>
+          <a:xfrm>
+            <a:off x="228600" y="91440"/>
+            <a:ext cx="8686800" cy="3200400"/>
+          </a:xfrm>
+          <a:prstGeom prst="rect">
+            <a:avLst/>
+          </a:prstGeom>
+          <a:noFill/>
+        </p:spPr>
+        <p:txBody>
+          <a:bodyPr wrap="square">
+            <a:spAutoFit/>
+          </a:bodyPr>
+          <a:lstStyle/>
+          <a:p>
+            <a:pPr algn="ctr"/>
+            <a:r>
+              <a:rPr sz="3200" b="1">
+                <a:solidFill>
+                  <a:srgbClr val="FFFF00"/>
+                </a:solidFill>
+                <a:latin typeface="微軟正黑體"/>
+              </a:rPr>
+              <a:t>§ 不停地叩門 不停地尋求</a:t>
+            </a:r>
+            <a:br/>
+            <a:r>
+              <a:rPr sz="3200" b="1">
+                <a:solidFill>
+                  <a:srgbClr val="FFFF00"/>
+                </a:solidFill>
+                <a:latin typeface="微軟正黑體"/>
+              </a:rPr>
+              <a:t>天上的門為我們打開</a:t>
+            </a:r>
+          </a:p>
+        </p:txBody>
+      </p:sp>
+      <p:sp>
+        <p:nvSpPr>
+          <p:cNvPr id="3" name="TextBox 2"/>
+          <p:cNvSpPr txBox="1"/>
+          <p:nvPr/>
+        </p:nvSpPr>
+        <p:spPr>
+          <a:xfrm>
+            <a:off x="228600" y="4572000"/>
+            <a:ext cx="8686800" cy="457200"/>
+          </a:xfrm>
+          <a:prstGeom prst="rect">
+            <a:avLst/>
+          </a:prstGeom>
+          <a:noFill/>
+        </p:spPr>
+        <p:txBody>
+          <a:bodyPr wrap="none">
+            <a:spAutoFit/>
+          </a:bodyPr>
+          <a:lstStyle/>
+          <a:p>
+            <a:pPr algn="ctr"/>
+            <a:r>
+              <a:rPr sz="2000" b="0">
+                <a:solidFill>
+                  <a:srgbClr val="FFFF00"/>
+                </a:solidFill>
+                <a:latin typeface="微軟正黑體"/>
+              </a:rPr>
+              <a:t>《我渴望看見》</a:t>
+            </a:r>
+          </a:p>
+        </p:txBody>
+      </p:sp>
+    </p:spTree>
+  </p:cSld>
+  <p:clrMapOvr>
+    <a:masterClrMapping/>
+  </p:clrMapOvr>
+</p:sld>
+</file>
+
+<file path=ppt/slides/slide24.xml><?xml version="1.0" encoding="utf-8"?>
+<p:sld xmlns:a="http://schemas.openxmlformats.org/drawingml/2006/main" xmlns:p="http://schemas.openxmlformats.org/presentationml/2006/main" xmlns:r="http://schemas.openxmlformats.org/officeDocument/2006/relationships">
+  <p:cSld>
+    <p:bg>
+      <p:bgPr>
+        <a:solidFill>
+          <a:srgbClr val="000000"/>
+        </a:solidFill>
+        <a:effectLst/>
+      </p:bgPr>
+    </p:bg>
+    <p:spTree>
+      <p:nvGrpSpPr>
+        <p:cNvPr id="1" name=""/>
+        <p:cNvGrpSpPr/>
+        <p:nvPr/>
+      </p:nvGrpSpPr>
+      <p:grpSpPr/>
+      <p:sp>
+        <p:nvSpPr>
+          <p:cNvPr id="2" name="TextBox 1"/>
+          <p:cNvSpPr txBox="1"/>
+          <p:nvPr/>
+        </p:nvSpPr>
+        <p:spPr>
+          <a:xfrm>
+            <a:off x="228600" y="91440"/>
+            <a:ext cx="8686800" cy="3200400"/>
+          </a:xfrm>
+          <a:prstGeom prst="rect">
+            <a:avLst/>
+          </a:prstGeom>
+          <a:noFill/>
+        </p:spPr>
+        <p:txBody>
+          <a:bodyPr wrap="square">
+            <a:spAutoFit/>
+          </a:bodyPr>
+          <a:lstStyle/>
+          <a:p>
+            <a:pPr algn="ctr"/>
+            <a:r>
+              <a:rPr sz="3200" b="1">
+                <a:solidFill>
+                  <a:srgbClr val="FFFF00"/>
+                </a:solidFill>
+                <a:latin typeface="微軟正黑體"/>
+              </a:rPr>
+              <a:t>不停地禱告 不停地呼喊</a:t>
+            </a:r>
+            <a:br/>
+            <a:r>
+              <a:rPr sz="3200" b="1">
+                <a:solidFill>
+                  <a:srgbClr val="FFFF00"/>
+                </a:solidFill>
+                <a:latin typeface="微軟正黑體"/>
+              </a:rPr>
+              <a:t>呼求復興臨到這世代</a:t>
+            </a:r>
+          </a:p>
+        </p:txBody>
+      </p:sp>
+      <p:sp>
+        <p:nvSpPr>
+          <p:cNvPr id="3" name="TextBox 2"/>
+          <p:cNvSpPr txBox="1"/>
+          <p:nvPr/>
+        </p:nvSpPr>
+        <p:spPr>
+          <a:xfrm>
+            <a:off x="228600" y="4572000"/>
+            <a:ext cx="8686800" cy="457200"/>
+          </a:xfrm>
+          <a:prstGeom prst="rect">
+            <a:avLst/>
+          </a:prstGeom>
+          <a:noFill/>
+        </p:spPr>
+        <p:txBody>
+          <a:bodyPr wrap="none">
+            <a:spAutoFit/>
+          </a:bodyPr>
+          <a:lstStyle/>
+          <a:p>
+            <a:pPr algn="ctr"/>
+            <a:r>
+              <a:rPr sz="2000" b="0">
+                <a:solidFill>
+                  <a:srgbClr val="FFFF00"/>
+                </a:solidFill>
+                <a:latin typeface="微軟正黑體"/>
+              </a:rPr>
+              <a:t>《我渴望看見》</a:t>
+            </a:r>
+          </a:p>
+        </p:txBody>
+      </p:sp>
+    </p:spTree>
+  </p:cSld>
+  <p:clrMapOvr>
+    <a:masterClrMapping/>
+  </p:clrMapOvr>
+</p:sld>
+</file>
+
+<file path=ppt/slides/slide25.xml><?xml version="1.0" encoding="utf-8"?>
+<p:sld xmlns:a="http://schemas.openxmlformats.org/drawingml/2006/main" xmlns:p="http://schemas.openxmlformats.org/presentationml/2006/main" xmlns:r="http://schemas.openxmlformats.org/officeDocument/2006/relationships">
+  <p:cSld>
+    <p:bg>
+      <p:bgPr>
+        <a:solidFill>
+          <a:srgbClr val="000000"/>
+        </a:solidFill>
+        <a:effectLst/>
+      </p:bgPr>
+    </p:bg>
+    <p:spTree>
+      <p:nvGrpSpPr>
+        <p:cNvPr id="1" name=""/>
+        <p:cNvGrpSpPr/>
+        <p:nvPr/>
+      </p:nvGrpSpPr>
+      <p:grpSpPr/>
+      <p:sp>
+        <p:nvSpPr>
+          <p:cNvPr id="2" name="TextBox 1"/>
+          <p:cNvSpPr txBox="1"/>
+          <p:nvPr/>
+        </p:nvSpPr>
+        <p:spPr>
+          <a:xfrm>
+            <a:off x="228600" y="91440"/>
+            <a:ext cx="8686800" cy="3200400"/>
+          </a:xfrm>
+          <a:prstGeom prst="rect">
+            <a:avLst/>
+          </a:prstGeom>
+          <a:noFill/>
+        </p:spPr>
+        <p:txBody>
+          <a:bodyPr wrap="square">
+            <a:spAutoFit/>
+          </a:bodyPr>
+          <a:lstStyle/>
+          <a:p>
+            <a:pPr algn="ctr"/>
+            <a:r>
+              <a:rPr sz="3200" b="1">
+                <a:solidFill>
+                  <a:srgbClr val="FFFF00"/>
+                </a:solidFill>
+                <a:latin typeface="微軟正黑體"/>
+              </a:rPr>
+              <a:t>我們在叩門 我們在尋求</a:t>
+            </a:r>
+            <a:br/>
+            <a:r>
+              <a:rPr sz="3200" b="1">
+                <a:solidFill>
+                  <a:srgbClr val="FFFF00"/>
+                </a:solidFill>
+                <a:latin typeface="微軟正黑體"/>
+              </a:rPr>
+              <a:t>天上的門為我們打開</a:t>
+            </a:r>
+          </a:p>
+        </p:txBody>
+      </p:sp>
+      <p:sp>
+        <p:nvSpPr>
+          <p:cNvPr id="3" name="TextBox 2"/>
+          <p:cNvSpPr txBox="1"/>
+          <p:nvPr/>
+        </p:nvSpPr>
+        <p:spPr>
+          <a:xfrm>
+            <a:off x="228600" y="4572000"/>
+            <a:ext cx="8686800" cy="457200"/>
+          </a:xfrm>
+          <a:prstGeom prst="rect">
+            <a:avLst/>
+          </a:prstGeom>
+          <a:noFill/>
+        </p:spPr>
+        <p:txBody>
+          <a:bodyPr wrap="none">
+            <a:spAutoFit/>
+          </a:bodyPr>
+          <a:lstStyle/>
+          <a:p>
+            <a:pPr algn="ctr"/>
+            <a:r>
+              <a:rPr sz="2000" b="0">
+                <a:solidFill>
+                  <a:srgbClr val="FFFF00"/>
+                </a:solidFill>
+                <a:latin typeface="微軟正黑體"/>
+              </a:rPr>
+              <a:t>《我渴望看見》</a:t>
+            </a:r>
+          </a:p>
+        </p:txBody>
+      </p:sp>
+    </p:spTree>
+  </p:cSld>
+  <p:clrMapOvr>
+    <a:masterClrMapping/>
+  </p:clrMapOvr>
+</p:sld>
+</file>
+
+<file path=ppt/slides/slide26.xml><?xml version="1.0" encoding="utf-8"?>
+<p:sld xmlns:a="http://schemas.openxmlformats.org/drawingml/2006/main" xmlns:p="http://schemas.openxmlformats.org/presentationml/2006/main" xmlns:r="http://schemas.openxmlformats.org/officeDocument/2006/relationships">
+  <p:cSld>
+    <p:bg>
+      <p:bgPr>
+        <a:solidFill>
+          <a:srgbClr val="000000"/>
+        </a:solidFill>
+        <a:effectLst/>
+      </p:bgPr>
+    </p:bg>
+    <p:spTree>
+      <p:nvGrpSpPr>
+        <p:cNvPr id="1" name=""/>
+        <p:cNvGrpSpPr/>
+        <p:nvPr/>
+      </p:nvGrpSpPr>
+      <p:grpSpPr/>
+      <p:sp>
+        <p:nvSpPr>
+          <p:cNvPr id="2" name="TextBox 1"/>
+          <p:cNvSpPr txBox="1"/>
+          <p:nvPr/>
+        </p:nvSpPr>
+        <p:spPr>
+          <a:xfrm>
+            <a:off x="228600" y="91440"/>
+            <a:ext cx="8686800" cy="3200400"/>
+          </a:xfrm>
+          <a:prstGeom prst="rect">
+            <a:avLst/>
+          </a:prstGeom>
+          <a:noFill/>
+        </p:spPr>
+        <p:txBody>
+          <a:bodyPr wrap="square">
+            <a:spAutoFit/>
+          </a:bodyPr>
+          <a:lstStyle/>
+          <a:p>
+            <a:pPr algn="ctr"/>
+            <a:r>
+              <a:rPr sz="3200" b="1">
+                <a:solidFill>
+                  <a:srgbClr val="FFFF00"/>
+                </a:solidFill>
+                <a:latin typeface="微軟正黑體"/>
+              </a:rPr>
+              <a:t>我們在禱告 我們在呼喊</a:t>
+            </a:r>
+            <a:br/>
+            <a:r>
+              <a:rPr sz="3200" b="1">
+                <a:solidFill>
+                  <a:srgbClr val="FFFF00"/>
+                </a:solidFill>
+                <a:latin typeface="微軟正黑體"/>
+              </a:rPr>
+              <a:t>呼求復興臨到這世代</a:t>
+            </a:r>
+          </a:p>
+        </p:txBody>
+      </p:sp>
+      <p:sp>
+        <p:nvSpPr>
+          <p:cNvPr id="3" name="TextBox 2"/>
+          <p:cNvSpPr txBox="1"/>
+          <p:nvPr/>
+        </p:nvSpPr>
+        <p:spPr>
+          <a:xfrm>
+            <a:off x="228600" y="4572000"/>
+            <a:ext cx="8686800" cy="457200"/>
+          </a:xfrm>
+          <a:prstGeom prst="rect">
+            <a:avLst/>
+          </a:prstGeom>
+          <a:noFill/>
+        </p:spPr>
+        <p:txBody>
+          <a:bodyPr wrap="none">
+            <a:spAutoFit/>
+          </a:bodyPr>
+          <a:lstStyle/>
+          <a:p>
+            <a:pPr algn="ctr"/>
+            <a:r>
+              <a:rPr sz="2000" b="0">
+                <a:solidFill>
+                  <a:srgbClr val="FFFF00"/>
+                </a:solidFill>
+                <a:latin typeface="微軟正黑體"/>
+              </a:rPr>
+              <a:t>《我渴望看見》</a:t>
+            </a:r>
+          </a:p>
+        </p:txBody>
+      </p:sp>
+    </p:spTree>
+  </p:cSld>
+  <p:clrMapOvr>
+    <a:masterClrMapping/>
+  </p:clrMapOvr>
+</p:sld>
+</file>
+
+<file path=ppt/slides/slide27.xml><?xml version="1.0" encoding="utf-8"?>
+<p:sld xmlns:a="http://schemas.openxmlformats.org/drawingml/2006/main" xmlns:p="http://schemas.openxmlformats.org/presentationml/2006/main" xmlns:r="http://schemas.openxmlformats.org/officeDocument/2006/relationships">
+  <p:cSld>
+    <p:bg>
+      <p:bgPr>
+        <a:solidFill>
+          <a:srgbClr val="000000"/>
+        </a:solidFill>
+        <a:effectLst/>
+      </p:bgPr>
+    </p:bg>
+    <p:spTree>
+      <p:nvGrpSpPr>
+        <p:cNvPr id="1" name=""/>
+        <p:cNvGrpSpPr/>
+        <p:nvPr/>
+      </p:nvGrpSpPr>
+      <p:grpSpPr/>
+      <p:sp>
+        <p:nvSpPr>
+          <p:cNvPr id="2" name="TextBox 1"/>
+          <p:cNvSpPr txBox="1"/>
+          <p:nvPr/>
+        </p:nvSpPr>
+        <p:spPr>
+          <a:xfrm>
+            <a:off x="228600" y="91440"/>
+            <a:ext cx="8686800" cy="3200400"/>
+          </a:xfrm>
+          <a:prstGeom prst="rect">
+            <a:avLst/>
+          </a:prstGeom>
+          <a:noFill/>
+        </p:spPr>
+        <p:txBody>
+          <a:bodyPr wrap="square">
+            <a:spAutoFit/>
+          </a:bodyPr>
+          <a:lstStyle/>
+          <a:p>
+            <a:pPr algn="ctr"/>
+            <a:r>
+              <a:rPr sz="3200" b="1">
+                <a:solidFill>
+                  <a:srgbClr val="FFFF00"/>
+                </a:solidFill>
+                <a:latin typeface="微軟正黑體"/>
+              </a:rPr>
+              <a:t>1.有敬拜的聲音發出</a:t>
+            </a:r>
+            <a:br/>
+            <a:r>
+              <a:rPr sz="3200" b="1">
+                <a:solidFill>
+                  <a:srgbClr val="FFFF00"/>
+                </a:solidFill>
+                <a:latin typeface="微軟正黑體"/>
+              </a:rPr>
+              <a:t>從最高的山到海洋深處</a:t>
+            </a:r>
+          </a:p>
+        </p:txBody>
+      </p:sp>
+      <p:sp>
+        <p:nvSpPr>
+          <p:cNvPr id="3" name="TextBox 2"/>
+          <p:cNvSpPr txBox="1"/>
+          <p:nvPr/>
+        </p:nvSpPr>
+        <p:spPr>
+          <a:xfrm>
+            <a:off x="228600" y="4572000"/>
+            <a:ext cx="8686800" cy="457200"/>
+          </a:xfrm>
+          <a:prstGeom prst="rect">
+            <a:avLst/>
+          </a:prstGeom>
+          <a:noFill/>
+        </p:spPr>
+        <p:txBody>
+          <a:bodyPr wrap="none">
+            <a:spAutoFit/>
+          </a:bodyPr>
+          <a:lstStyle/>
+          <a:p>
+            <a:pPr algn="ctr"/>
+            <a:r>
+              <a:rPr sz="2000" b="0">
+                <a:solidFill>
+                  <a:srgbClr val="FFFF00"/>
+                </a:solidFill>
+                <a:latin typeface="微軟正黑體"/>
+              </a:rPr>
+              <a:t>《新的異象新的方向》</a:t>
+            </a:r>
+          </a:p>
+        </p:txBody>
+      </p:sp>
+    </p:spTree>
+  </p:cSld>
+  <p:clrMapOvr>
+    <a:masterClrMapping/>
+  </p:clrMapOvr>
+</p:sld>
+</file>
+
+<file path=ppt/slides/slide28.xml><?xml version="1.0" encoding="utf-8"?>
+<p:sld xmlns:a="http://schemas.openxmlformats.org/drawingml/2006/main" xmlns:p="http://schemas.openxmlformats.org/presentationml/2006/main" xmlns:r="http://schemas.openxmlformats.org/officeDocument/2006/relationships">
+  <p:cSld>
+    <p:bg>
+      <p:bgPr>
+        <a:solidFill>
+          <a:srgbClr val="000000"/>
+        </a:solidFill>
+        <a:effectLst/>
+      </p:bgPr>
+    </p:bg>
+    <p:spTree>
+      <p:nvGrpSpPr>
+        <p:cNvPr id="1" name=""/>
+        <p:cNvGrpSpPr/>
+        <p:nvPr/>
+      </p:nvGrpSpPr>
+      <p:grpSpPr/>
+      <p:sp>
+        <p:nvSpPr>
+          <p:cNvPr id="2" name="TextBox 1"/>
+          <p:cNvSpPr txBox="1"/>
+          <p:nvPr/>
+        </p:nvSpPr>
+        <p:spPr>
+          <a:xfrm>
+            <a:off x="228600" y="91440"/>
+            <a:ext cx="8686800" cy="3200400"/>
+          </a:xfrm>
+          <a:prstGeom prst="rect">
+            <a:avLst/>
+          </a:prstGeom>
+          <a:noFill/>
+        </p:spPr>
+        <p:txBody>
+          <a:bodyPr wrap="square">
+            <a:spAutoFit/>
+          </a:bodyPr>
+          <a:lstStyle/>
+          <a:p>
+            <a:pPr algn="ctr"/>
+            <a:r>
+              <a:rPr sz="3200" b="1">
+                <a:solidFill>
+                  <a:srgbClr val="FFFF00"/>
+                </a:solidFill>
+                <a:latin typeface="微軟正黑體"/>
+              </a:rPr>
+              <a:t>神的兒女要唱一首新歌</a:t>
+            </a:r>
+            <a:br/>
+            <a:r>
+              <a:rPr sz="3200" b="1">
+                <a:solidFill>
+                  <a:srgbClr val="FFFF00"/>
+                </a:solidFill>
+                <a:latin typeface="微軟正黑體"/>
+              </a:rPr>
+              <a:t>我們神要做新事</a:t>
+            </a:r>
+          </a:p>
+        </p:txBody>
+      </p:sp>
+      <p:sp>
+        <p:nvSpPr>
+          <p:cNvPr id="3" name="TextBox 2"/>
+          <p:cNvSpPr txBox="1"/>
+          <p:nvPr/>
+        </p:nvSpPr>
+        <p:spPr>
+          <a:xfrm>
+            <a:off x="228600" y="4572000"/>
+            <a:ext cx="8686800" cy="457200"/>
+          </a:xfrm>
+          <a:prstGeom prst="rect">
+            <a:avLst/>
+          </a:prstGeom>
+          <a:noFill/>
+        </p:spPr>
+        <p:txBody>
+          <a:bodyPr wrap="none">
+            <a:spAutoFit/>
+          </a:bodyPr>
+          <a:lstStyle/>
+          <a:p>
+            <a:pPr algn="ctr"/>
+            <a:r>
+              <a:rPr sz="2000" b="0">
+                <a:solidFill>
+                  <a:srgbClr val="FFFF00"/>
+                </a:solidFill>
+                <a:latin typeface="微軟正黑體"/>
+              </a:rPr>
+              <a:t>《新的異象新的方向》</a:t>
+            </a:r>
+          </a:p>
+        </p:txBody>
+      </p:sp>
+    </p:spTree>
+  </p:cSld>
+  <p:clrMapOvr>
+    <a:masterClrMapping/>
+  </p:clrMapOvr>
+</p:sld>
+</file>
+
+<file path=ppt/slides/slide29.xml><?xml version="1.0" encoding="utf-8"?>
+<p:sld xmlns:a="http://schemas.openxmlformats.org/drawingml/2006/main" xmlns:p="http://schemas.openxmlformats.org/presentationml/2006/main" xmlns:r="http://schemas.openxmlformats.org/officeDocument/2006/relationships">
+  <p:cSld>
+    <p:bg>
+      <p:bgPr>
+        <a:solidFill>
+          <a:srgbClr val="000000"/>
+        </a:solidFill>
+        <a:effectLst/>
+      </p:bgPr>
+    </p:bg>
+    <p:spTree>
+      <p:nvGrpSpPr>
+        <p:cNvPr id="1" name=""/>
+        <p:cNvGrpSpPr/>
+        <p:nvPr/>
+      </p:nvGrpSpPr>
+      <p:grpSpPr/>
+      <p:sp>
+        <p:nvSpPr>
+          <p:cNvPr id="2" name="TextBox 1"/>
+          <p:cNvSpPr txBox="1"/>
+          <p:nvPr/>
+        </p:nvSpPr>
+        <p:spPr>
+          <a:xfrm>
+            <a:off x="228600" y="91440"/>
+            <a:ext cx="8686800" cy="3200400"/>
+          </a:xfrm>
+          <a:prstGeom prst="rect">
+            <a:avLst/>
+          </a:prstGeom>
+          <a:noFill/>
+        </p:spPr>
+        <p:txBody>
+          <a:bodyPr wrap="square">
+            <a:spAutoFit/>
+          </a:bodyPr>
+          <a:lstStyle/>
+          <a:p>
+            <a:pPr algn="ctr"/>
+            <a:r>
+              <a:rPr sz="3200" b="1">
+                <a:solidFill>
+                  <a:srgbClr val="FFFF00"/>
+                </a:solidFill>
+                <a:latin typeface="微軟正黑體"/>
+              </a:rPr>
+              <a:t>2.舊的事都已經過去</a:t>
+            </a:r>
+            <a:br/>
+            <a:r>
+              <a:rPr sz="3200" b="1">
+                <a:solidFill>
+                  <a:srgbClr val="FFFF00"/>
+                </a:solidFill>
+                <a:latin typeface="微軟正黑體"/>
+              </a:rPr>
+              <a:t>在基督裡一切都要更新</a:t>
+            </a:r>
+          </a:p>
+        </p:txBody>
+      </p:sp>
+      <p:sp>
+        <p:nvSpPr>
+          <p:cNvPr id="3" name="TextBox 2"/>
+          <p:cNvSpPr txBox="1"/>
+          <p:nvPr/>
+        </p:nvSpPr>
+        <p:spPr>
+          <a:xfrm>
+            <a:off x="228600" y="4572000"/>
+            <a:ext cx="8686800" cy="457200"/>
+          </a:xfrm>
+          <a:prstGeom prst="rect">
+            <a:avLst/>
+          </a:prstGeom>
+          <a:noFill/>
+        </p:spPr>
+        <p:txBody>
+          <a:bodyPr wrap="none">
+            <a:spAutoFit/>
+          </a:bodyPr>
+          <a:lstStyle/>
+          <a:p>
+            <a:pPr algn="ctr"/>
+            <a:r>
+              <a:rPr sz="2000" b="0">
+                <a:solidFill>
+                  <a:srgbClr val="FFFF00"/>
+                </a:solidFill>
+                <a:latin typeface="微軟正黑體"/>
+              </a:rPr>
+              <a:t>《新的異象新的方向》</a:t>
             </a:r>
           </a:p>
         </p:txBody>
@@ -3318,8 +5469,53 @@
         </p:nvSpPr>
         <p:spPr>
           <a:xfrm>
-            <a:off x="457200" y="91440"/>
-            <a:ext cx="8229600" cy="2286000"/>
+            <a:off x="228600" y="91440"/>
+            <a:ext cx="8686800" cy="3200400"/>
+          </a:xfrm>
+          <a:prstGeom prst="rect">
+            <a:avLst/>
+          </a:prstGeom>
+          <a:noFill/>
+        </p:spPr>
+        <p:txBody>
+          <a:bodyPr wrap="square">
+            <a:spAutoFit/>
+          </a:bodyPr>
+          <a:lstStyle/>
+          <a:p>
+            <a:pPr algn="ctr"/>
+            <a:r>
+              <a:rPr sz="3200" b="1">
+                <a:solidFill>
+                  <a:srgbClr val="FFFF00"/>
+                </a:solidFill>
+                <a:latin typeface="微軟正黑體"/>
+              </a:rPr>
+              <a:t>※祢眼目必看顧這地 眷顧祢的兒女</a:t>
+            </a:r>
+            <a:br/>
+            <a:r>
+              <a:rPr sz="3200" b="1">
+                <a:solidFill>
+                  <a:srgbClr val="FFFF00"/>
+                </a:solidFill>
+                <a:latin typeface="微軟正黑體"/>
+              </a:rPr>
+              <a:t>祢必照所應許的成就</a:t>
+            </a:r>
+          </a:p>
+        </p:txBody>
+      </p:sp>
+      <p:sp>
+        <p:nvSpPr>
+          <p:cNvPr id="3" name="TextBox 2"/>
+          <p:cNvSpPr txBox="1"/>
+          <p:nvPr/>
+        </p:nvSpPr>
+        <p:spPr>
+          <a:xfrm>
+            <a:off x="228600" y="4572000"/>
+            <a:ext cx="8686800" cy="457200"/>
           </a:xfrm>
           <a:prstGeom prst="rect">
             <a:avLst/>
@@ -3334,13 +5530,74 @@
           <a:p>
             <a:pPr algn="ctr"/>
             <a:r>
+              <a:rPr sz="2000" b="0">
+                <a:solidFill>
+                  <a:srgbClr val="FFFF00"/>
+                </a:solidFill>
+                <a:latin typeface="微軟正黑體"/>
+              </a:rPr>
+              <a:t>《祢眼目必看顧這地》</a:t>
+            </a:r>
+          </a:p>
+        </p:txBody>
+      </p:sp>
+    </p:spTree>
+  </p:cSld>
+  <p:clrMapOvr>
+    <a:masterClrMapping/>
+  </p:clrMapOvr>
+</p:sld>
+</file>
+
+<file path=ppt/slides/slide30.xml><?xml version="1.0" encoding="utf-8"?>
+<p:sld xmlns:a="http://schemas.openxmlformats.org/drawingml/2006/main" xmlns:p="http://schemas.openxmlformats.org/presentationml/2006/main" xmlns:r="http://schemas.openxmlformats.org/officeDocument/2006/relationships">
+  <p:cSld>
+    <p:bg>
+      <p:bgPr>
+        <a:solidFill>
+          <a:srgbClr val="000000"/>
+        </a:solidFill>
+        <a:effectLst/>
+      </p:bgPr>
+    </p:bg>
+    <p:spTree>
+      <p:nvGrpSpPr>
+        <p:cNvPr id="1" name=""/>
+        <p:cNvGrpSpPr/>
+        <p:nvPr/>
+      </p:nvGrpSpPr>
+      <p:grpSpPr/>
+      <p:sp>
+        <p:nvSpPr>
+          <p:cNvPr id="2" name="TextBox 1"/>
+          <p:cNvSpPr txBox="1"/>
+          <p:nvPr/>
+        </p:nvSpPr>
+        <p:spPr>
+          <a:xfrm>
+            <a:off x="228600" y="91440"/>
+            <a:ext cx="8686800" cy="3200400"/>
+          </a:xfrm>
+          <a:prstGeom prst="rect">
+            <a:avLst/>
+          </a:prstGeom>
+          <a:noFill/>
+        </p:spPr>
+        <p:txBody>
+          <a:bodyPr wrap="square">
+            <a:spAutoFit/>
+          </a:bodyPr>
+          <a:lstStyle/>
+          <a:p>
+            <a:pPr algn="ctr"/>
+            <a:r>
               <a:rPr sz="3200" b="1">
                 <a:solidFill>
                   <a:srgbClr val="FFFF00"/>
                 </a:solidFill>
                 <a:latin typeface="微軟正黑體"/>
               </a:rPr>
-              <a:t>耶穌我愛你 俯伏在你面前 讚美敬拜你 主～我王</a:t>
+              <a:t>新的眼界 新的異象</a:t>
             </a:r>
             <a:br/>
             <a:r>
@@ -3350,7 +5607,7 @@
                 </a:solidFill>
                 <a:latin typeface="微軟正黑體"/>
               </a:rPr>
-              <a:t>哈利路亞 哈利路亞 哈利路亞 哈利路 </a:t>
+              <a:t>新的故事 新的方向</a:t>
             </a:r>
           </a:p>
         </p:txBody>
@@ -3363,8 +5620,8 @@
         </p:nvSpPr>
         <p:spPr>
           <a:xfrm>
-            <a:off x="457200" y="4663440"/>
-            <a:ext cx="8229600" cy="457200"/>
+            <a:off x="228600" y="4572000"/>
+            <a:ext cx="8686800" cy="457200"/>
           </a:xfrm>
           <a:prstGeom prst="rect">
             <a:avLst/>
@@ -3385,7 +5642,1067 @@
                 </a:solidFill>
                 <a:latin typeface="微軟正黑體"/>
               </a:rPr>
-              <a:t>《耶穌我愛祢》</a:t>
+              <a:t>《新的異象新的方向》</a:t>
+            </a:r>
+          </a:p>
+        </p:txBody>
+      </p:sp>
+    </p:spTree>
+  </p:cSld>
+  <p:clrMapOvr>
+    <a:masterClrMapping/>
+  </p:clrMapOvr>
+</p:sld>
+</file>
+
+<file path=ppt/slides/slide31.xml><?xml version="1.0" encoding="utf-8"?>
+<p:sld xmlns:a="http://schemas.openxmlformats.org/drawingml/2006/main" xmlns:p="http://schemas.openxmlformats.org/presentationml/2006/main" xmlns:r="http://schemas.openxmlformats.org/officeDocument/2006/relationships">
+  <p:cSld>
+    <p:bg>
+      <p:bgPr>
+        <a:solidFill>
+          <a:srgbClr val="000000"/>
+        </a:solidFill>
+        <a:effectLst/>
+      </p:bgPr>
+    </p:bg>
+    <p:spTree>
+      <p:nvGrpSpPr>
+        <p:cNvPr id="1" name=""/>
+        <p:cNvGrpSpPr/>
+        <p:nvPr/>
+      </p:nvGrpSpPr>
+      <p:grpSpPr/>
+      <p:sp>
+        <p:nvSpPr>
+          <p:cNvPr id="2" name="TextBox 1"/>
+          <p:cNvSpPr txBox="1"/>
+          <p:nvPr/>
+        </p:nvSpPr>
+        <p:spPr>
+          <a:xfrm>
+            <a:off x="228600" y="91440"/>
+            <a:ext cx="8686800" cy="3200400"/>
+          </a:xfrm>
+          <a:prstGeom prst="rect">
+            <a:avLst/>
+          </a:prstGeom>
+          <a:noFill/>
+        </p:spPr>
+        <p:txBody>
+          <a:bodyPr wrap="square">
+            <a:spAutoFit/>
+          </a:bodyPr>
+          <a:lstStyle/>
+          <a:p>
+            <a:pPr algn="ctr"/>
+            <a:r>
+              <a:rPr sz="3200" b="1">
+                <a:solidFill>
+                  <a:srgbClr val="FFFF00"/>
+                </a:solidFill>
+                <a:latin typeface="微軟正黑體"/>
+              </a:rPr>
+              <a:t>※全地都要渴望呼喊</a:t>
+            </a:r>
+            <a:br/>
+            <a:r>
+              <a:rPr sz="3200" b="1">
+                <a:solidFill>
+                  <a:srgbClr val="FFFF00"/>
+                </a:solidFill>
+                <a:latin typeface="微軟正黑體"/>
+              </a:rPr>
+              <a:t>榮耀的主我願祢來</a:t>
+            </a:r>
+          </a:p>
+        </p:txBody>
+      </p:sp>
+      <p:sp>
+        <p:nvSpPr>
+          <p:cNvPr id="3" name="TextBox 2"/>
+          <p:cNvSpPr txBox="1"/>
+          <p:nvPr/>
+        </p:nvSpPr>
+        <p:spPr>
+          <a:xfrm>
+            <a:off x="228600" y="4572000"/>
+            <a:ext cx="8686800" cy="457200"/>
+          </a:xfrm>
+          <a:prstGeom prst="rect">
+            <a:avLst/>
+          </a:prstGeom>
+          <a:noFill/>
+        </p:spPr>
+        <p:txBody>
+          <a:bodyPr wrap="none">
+            <a:spAutoFit/>
+          </a:bodyPr>
+          <a:lstStyle/>
+          <a:p>
+            <a:pPr algn="ctr"/>
+            <a:r>
+              <a:rPr sz="2000" b="0">
+                <a:solidFill>
+                  <a:srgbClr val="FFFF00"/>
+                </a:solidFill>
+                <a:latin typeface="微軟正黑體"/>
+              </a:rPr>
+              <a:t>《新的異象新的方向》</a:t>
+            </a:r>
+          </a:p>
+        </p:txBody>
+      </p:sp>
+    </p:spTree>
+  </p:cSld>
+  <p:clrMapOvr>
+    <a:masterClrMapping/>
+  </p:clrMapOvr>
+</p:sld>
+</file>
+
+<file path=ppt/slides/slide32.xml><?xml version="1.0" encoding="utf-8"?>
+<p:sld xmlns:a="http://schemas.openxmlformats.org/drawingml/2006/main" xmlns:p="http://schemas.openxmlformats.org/presentationml/2006/main" xmlns:r="http://schemas.openxmlformats.org/officeDocument/2006/relationships">
+  <p:cSld>
+    <p:bg>
+      <p:bgPr>
+        <a:solidFill>
+          <a:srgbClr val="000000"/>
+        </a:solidFill>
+        <a:effectLst/>
+      </p:bgPr>
+    </p:bg>
+    <p:spTree>
+      <p:nvGrpSpPr>
+        <p:cNvPr id="1" name=""/>
+        <p:cNvGrpSpPr/>
+        <p:nvPr/>
+      </p:nvGrpSpPr>
+      <p:grpSpPr/>
+      <p:sp>
+        <p:nvSpPr>
+          <p:cNvPr id="2" name="TextBox 1"/>
+          <p:cNvSpPr txBox="1"/>
+          <p:nvPr/>
+        </p:nvSpPr>
+        <p:spPr>
+          <a:xfrm>
+            <a:off x="228600" y="91440"/>
+            <a:ext cx="8686800" cy="3200400"/>
+          </a:xfrm>
+          <a:prstGeom prst="rect">
+            <a:avLst/>
+          </a:prstGeom>
+          <a:noFill/>
+        </p:spPr>
+        <p:txBody>
+          <a:bodyPr wrap="square">
+            <a:spAutoFit/>
+          </a:bodyPr>
+          <a:lstStyle/>
+          <a:p>
+            <a:pPr algn="ctr"/>
+            <a:r>
+              <a:rPr sz="3200" b="1">
+                <a:solidFill>
+                  <a:srgbClr val="FFFF00"/>
+                </a:solidFill>
+                <a:latin typeface="微軟正黑體"/>
+              </a:rPr>
+              <a:t>天要敞開恩膏傾倒下來</a:t>
+            </a:r>
+            <a:br/>
+            <a:r>
+              <a:rPr sz="3200" b="1">
+                <a:solidFill>
+                  <a:srgbClr val="FFFF00"/>
+                </a:solidFill>
+                <a:latin typeface="微軟正黑體"/>
+              </a:rPr>
+              <a:t>神國度的榮耀彰顯</a:t>
+            </a:r>
+          </a:p>
+        </p:txBody>
+      </p:sp>
+      <p:sp>
+        <p:nvSpPr>
+          <p:cNvPr id="3" name="TextBox 2"/>
+          <p:cNvSpPr txBox="1"/>
+          <p:nvPr/>
+        </p:nvSpPr>
+        <p:spPr>
+          <a:xfrm>
+            <a:off x="228600" y="4572000"/>
+            <a:ext cx="8686800" cy="457200"/>
+          </a:xfrm>
+          <a:prstGeom prst="rect">
+            <a:avLst/>
+          </a:prstGeom>
+          <a:noFill/>
+        </p:spPr>
+        <p:txBody>
+          <a:bodyPr wrap="none">
+            <a:spAutoFit/>
+          </a:bodyPr>
+          <a:lstStyle/>
+          <a:p>
+            <a:pPr algn="ctr"/>
+            <a:r>
+              <a:rPr sz="2000" b="0">
+                <a:solidFill>
+                  <a:srgbClr val="FFFF00"/>
+                </a:solidFill>
+                <a:latin typeface="微軟正黑體"/>
+              </a:rPr>
+              <a:t>《新的異象新的方向》</a:t>
+            </a:r>
+          </a:p>
+        </p:txBody>
+      </p:sp>
+    </p:spTree>
+  </p:cSld>
+  <p:clrMapOvr>
+    <a:masterClrMapping/>
+  </p:clrMapOvr>
+</p:sld>
+</file>
+
+<file path=ppt/slides/slide33.xml><?xml version="1.0" encoding="utf-8"?>
+<p:sld xmlns:a="http://schemas.openxmlformats.org/drawingml/2006/main" xmlns:p="http://schemas.openxmlformats.org/presentationml/2006/main" xmlns:r="http://schemas.openxmlformats.org/officeDocument/2006/relationships">
+  <p:cSld>
+    <p:bg>
+      <p:bgPr>
+        <a:solidFill>
+          <a:srgbClr val="000000"/>
+        </a:solidFill>
+        <a:effectLst/>
+      </p:bgPr>
+    </p:bg>
+    <p:spTree>
+      <p:nvGrpSpPr>
+        <p:cNvPr id="1" name=""/>
+        <p:cNvGrpSpPr/>
+        <p:nvPr/>
+      </p:nvGrpSpPr>
+      <p:grpSpPr/>
+      <p:sp>
+        <p:nvSpPr>
+          <p:cNvPr id="2" name="TextBox 1"/>
+          <p:cNvSpPr txBox="1"/>
+          <p:nvPr/>
+        </p:nvSpPr>
+        <p:spPr>
+          <a:xfrm>
+            <a:off x="228600" y="91440"/>
+            <a:ext cx="8686800" cy="3200400"/>
+          </a:xfrm>
+          <a:prstGeom prst="rect">
+            <a:avLst/>
+          </a:prstGeom>
+          <a:noFill/>
+        </p:spPr>
+        <p:txBody>
+          <a:bodyPr wrap="square">
+            <a:spAutoFit/>
+          </a:bodyPr>
+          <a:lstStyle/>
+          <a:p>
+            <a:pPr algn="ctr"/>
+            <a:r>
+              <a:rPr sz="3200" b="1">
+                <a:solidFill>
+                  <a:srgbClr val="FFFF00"/>
+                </a:solidFill>
+                <a:latin typeface="微軟正黑體"/>
+              </a:rPr>
+              <a:t>全地都要渴望呼喊</a:t>
+            </a:r>
+            <a:br/>
+            <a:r>
+              <a:rPr sz="3200" b="1">
+                <a:solidFill>
+                  <a:srgbClr val="FFFF00"/>
+                </a:solidFill>
+                <a:latin typeface="微軟正黑體"/>
+              </a:rPr>
+              <a:t>榮耀的主我願祢來</a:t>
+            </a:r>
+          </a:p>
+        </p:txBody>
+      </p:sp>
+      <p:sp>
+        <p:nvSpPr>
+          <p:cNvPr id="3" name="TextBox 2"/>
+          <p:cNvSpPr txBox="1"/>
+          <p:nvPr/>
+        </p:nvSpPr>
+        <p:spPr>
+          <a:xfrm>
+            <a:off x="228600" y="4572000"/>
+            <a:ext cx="8686800" cy="457200"/>
+          </a:xfrm>
+          <a:prstGeom prst="rect">
+            <a:avLst/>
+          </a:prstGeom>
+          <a:noFill/>
+        </p:spPr>
+        <p:txBody>
+          <a:bodyPr wrap="none">
+            <a:spAutoFit/>
+          </a:bodyPr>
+          <a:lstStyle/>
+          <a:p>
+            <a:pPr algn="ctr"/>
+            <a:r>
+              <a:rPr sz="2000" b="0">
+                <a:solidFill>
+                  <a:srgbClr val="FFFF00"/>
+                </a:solidFill>
+                <a:latin typeface="微軟正黑體"/>
+              </a:rPr>
+              <a:t>《新的異象新的方向》</a:t>
+            </a:r>
+          </a:p>
+        </p:txBody>
+      </p:sp>
+    </p:spTree>
+  </p:cSld>
+  <p:clrMapOvr>
+    <a:masterClrMapping/>
+  </p:clrMapOvr>
+</p:sld>
+</file>
+
+<file path=ppt/slides/slide34.xml><?xml version="1.0" encoding="utf-8"?>
+<p:sld xmlns:a="http://schemas.openxmlformats.org/drawingml/2006/main" xmlns:p="http://schemas.openxmlformats.org/presentationml/2006/main" xmlns:r="http://schemas.openxmlformats.org/officeDocument/2006/relationships">
+  <p:cSld>
+    <p:bg>
+      <p:bgPr>
+        <a:solidFill>
+          <a:srgbClr val="000000"/>
+        </a:solidFill>
+        <a:effectLst/>
+      </p:bgPr>
+    </p:bg>
+    <p:spTree>
+      <p:nvGrpSpPr>
+        <p:cNvPr id="1" name=""/>
+        <p:cNvGrpSpPr/>
+        <p:nvPr/>
+      </p:nvGrpSpPr>
+      <p:grpSpPr/>
+      <p:sp>
+        <p:nvSpPr>
+          <p:cNvPr id="2" name="TextBox 1"/>
+          <p:cNvSpPr txBox="1"/>
+          <p:nvPr/>
+        </p:nvSpPr>
+        <p:spPr>
+          <a:xfrm>
+            <a:off x="228600" y="91440"/>
+            <a:ext cx="8686800" cy="3200400"/>
+          </a:xfrm>
+          <a:prstGeom prst="rect">
+            <a:avLst/>
+          </a:prstGeom>
+          <a:noFill/>
+        </p:spPr>
+        <p:txBody>
+          <a:bodyPr wrap="square">
+            <a:spAutoFit/>
+          </a:bodyPr>
+          <a:lstStyle/>
+          <a:p>
+            <a:pPr algn="ctr"/>
+            <a:r>
+              <a:rPr sz="3200" b="1">
+                <a:solidFill>
+                  <a:srgbClr val="FFFF00"/>
+                </a:solidFill>
+                <a:latin typeface="微軟正黑體"/>
+              </a:rPr>
+              <a:t>聖靈引領看見新的異象</a:t>
+            </a:r>
+            <a:br/>
+            <a:r>
+              <a:rPr sz="3200" b="1">
+                <a:solidFill>
+                  <a:srgbClr val="FFFF00"/>
+                </a:solidFill>
+                <a:latin typeface="微軟正黑體"/>
+              </a:rPr>
+              <a:t>祢要做新的事在我們中間</a:t>
+            </a:r>
+          </a:p>
+        </p:txBody>
+      </p:sp>
+      <p:sp>
+        <p:nvSpPr>
+          <p:cNvPr id="3" name="TextBox 2"/>
+          <p:cNvSpPr txBox="1"/>
+          <p:nvPr/>
+        </p:nvSpPr>
+        <p:spPr>
+          <a:xfrm>
+            <a:off x="228600" y="4572000"/>
+            <a:ext cx="8686800" cy="457200"/>
+          </a:xfrm>
+          <a:prstGeom prst="rect">
+            <a:avLst/>
+          </a:prstGeom>
+          <a:noFill/>
+        </p:spPr>
+        <p:txBody>
+          <a:bodyPr wrap="none">
+            <a:spAutoFit/>
+          </a:bodyPr>
+          <a:lstStyle/>
+          <a:p>
+            <a:pPr algn="ctr"/>
+            <a:r>
+              <a:rPr sz="2000" b="0">
+                <a:solidFill>
+                  <a:srgbClr val="FFFF00"/>
+                </a:solidFill>
+                <a:latin typeface="微軟正黑體"/>
+              </a:rPr>
+              <a:t>《新的異象新的方向》</a:t>
+            </a:r>
+          </a:p>
+        </p:txBody>
+      </p:sp>
+    </p:spTree>
+  </p:cSld>
+  <p:clrMapOvr>
+    <a:masterClrMapping/>
+  </p:clrMapOvr>
+</p:sld>
+</file>
+
+<file path=ppt/slides/slide4.xml><?xml version="1.0" encoding="utf-8"?>
+<p:sld xmlns:a="http://schemas.openxmlformats.org/drawingml/2006/main" xmlns:p="http://schemas.openxmlformats.org/presentationml/2006/main" xmlns:r="http://schemas.openxmlformats.org/officeDocument/2006/relationships">
+  <p:cSld>
+    <p:bg>
+      <p:bgPr>
+        <a:solidFill>
+          <a:srgbClr val="000000"/>
+        </a:solidFill>
+        <a:effectLst/>
+      </p:bgPr>
+    </p:bg>
+    <p:spTree>
+      <p:nvGrpSpPr>
+        <p:cNvPr id="1" name=""/>
+        <p:cNvGrpSpPr/>
+        <p:nvPr/>
+      </p:nvGrpSpPr>
+      <p:grpSpPr/>
+      <p:sp>
+        <p:nvSpPr>
+          <p:cNvPr id="2" name="TextBox 1"/>
+          <p:cNvSpPr txBox="1"/>
+          <p:nvPr/>
+        </p:nvSpPr>
+        <p:spPr>
+          <a:xfrm>
+            <a:off x="228600" y="91440"/>
+            <a:ext cx="8686800" cy="3200400"/>
+          </a:xfrm>
+          <a:prstGeom prst="rect">
+            <a:avLst/>
+          </a:prstGeom>
+          <a:noFill/>
+        </p:spPr>
+        <p:txBody>
+          <a:bodyPr wrap="square">
+            <a:spAutoFit/>
+          </a:bodyPr>
+          <a:lstStyle/>
+          <a:p>
+            <a:pPr algn="ctr"/>
+            <a:r>
+              <a:rPr sz="3200" b="1">
+                <a:solidFill>
+                  <a:srgbClr val="FFFF00"/>
+                </a:solidFill>
+                <a:latin typeface="微軟正黑體"/>
+              </a:rPr>
+              <a:t>祢眼目必看顧這地 聆聽我們聲音</a:t>
+            </a:r>
+            <a:br/>
+            <a:r>
+              <a:rPr sz="3200" b="1">
+                <a:solidFill>
+                  <a:srgbClr val="FFFF00"/>
+                </a:solidFill>
+                <a:latin typeface="微軟正黑體"/>
+              </a:rPr>
+              <a:t>禱告盼望榮耀復興降臨</a:t>
+            </a:r>
+          </a:p>
+        </p:txBody>
+      </p:sp>
+      <p:sp>
+        <p:nvSpPr>
+          <p:cNvPr id="3" name="TextBox 2"/>
+          <p:cNvSpPr txBox="1"/>
+          <p:nvPr/>
+        </p:nvSpPr>
+        <p:spPr>
+          <a:xfrm>
+            <a:off x="228600" y="4572000"/>
+            <a:ext cx="8686800" cy="457200"/>
+          </a:xfrm>
+          <a:prstGeom prst="rect">
+            <a:avLst/>
+          </a:prstGeom>
+          <a:noFill/>
+        </p:spPr>
+        <p:txBody>
+          <a:bodyPr wrap="none">
+            <a:spAutoFit/>
+          </a:bodyPr>
+          <a:lstStyle/>
+          <a:p>
+            <a:pPr algn="ctr"/>
+            <a:r>
+              <a:rPr sz="2000" b="0">
+                <a:solidFill>
+                  <a:srgbClr val="FFFF00"/>
+                </a:solidFill>
+                <a:latin typeface="微軟正黑體"/>
+              </a:rPr>
+              <a:t>《祢眼目必看顧這地》</a:t>
+            </a:r>
+          </a:p>
+        </p:txBody>
+      </p:sp>
+    </p:spTree>
+  </p:cSld>
+  <p:clrMapOvr>
+    <a:masterClrMapping/>
+  </p:clrMapOvr>
+</p:sld>
+</file>
+
+<file path=ppt/slides/slide5.xml><?xml version="1.0" encoding="utf-8"?>
+<p:sld xmlns:a="http://schemas.openxmlformats.org/drawingml/2006/main" xmlns:p="http://schemas.openxmlformats.org/presentationml/2006/main" xmlns:r="http://schemas.openxmlformats.org/officeDocument/2006/relationships">
+  <p:cSld>
+    <p:bg>
+      <p:bgPr>
+        <a:solidFill>
+          <a:srgbClr val="000000"/>
+        </a:solidFill>
+        <a:effectLst/>
+      </p:bgPr>
+    </p:bg>
+    <p:spTree>
+      <p:nvGrpSpPr>
+        <p:cNvPr id="1" name=""/>
+        <p:cNvGrpSpPr/>
+        <p:nvPr/>
+      </p:nvGrpSpPr>
+      <p:grpSpPr/>
+      <p:sp>
+        <p:nvSpPr>
+          <p:cNvPr id="2" name="TextBox 1"/>
+          <p:cNvSpPr txBox="1"/>
+          <p:nvPr/>
+        </p:nvSpPr>
+        <p:spPr>
+          <a:xfrm>
+            <a:off x="228600" y="91440"/>
+            <a:ext cx="8686800" cy="3200400"/>
+          </a:xfrm>
+          <a:prstGeom prst="rect">
+            <a:avLst/>
+          </a:prstGeom>
+          <a:noFill/>
+        </p:spPr>
+        <p:txBody>
+          <a:bodyPr wrap="square">
+            <a:spAutoFit/>
+          </a:bodyPr>
+          <a:lstStyle/>
+          <a:p>
+            <a:pPr algn="ctr"/>
+            <a:r>
+              <a:rPr sz="3200" b="1">
+                <a:solidFill>
+                  <a:srgbClr val="FFFF00"/>
+                </a:solidFill>
+                <a:latin typeface="微軟正黑體"/>
+              </a:rPr>
+              <a:t>§ 使我們得飽足 新酒和油滿溢</a:t>
+            </a:r>
+            <a:br/>
+            <a:r>
+              <a:rPr sz="3200" b="1">
+                <a:solidFill>
+                  <a:srgbClr val="FFFF00"/>
+                </a:solidFill>
+                <a:latin typeface="微軟正黑體"/>
+              </a:rPr>
+              <a:t>祢定意要賜福這地</a:t>
+            </a:r>
+          </a:p>
+        </p:txBody>
+      </p:sp>
+      <p:sp>
+        <p:nvSpPr>
+          <p:cNvPr id="3" name="TextBox 2"/>
+          <p:cNvSpPr txBox="1"/>
+          <p:nvPr/>
+        </p:nvSpPr>
+        <p:spPr>
+          <a:xfrm>
+            <a:off x="228600" y="4572000"/>
+            <a:ext cx="8686800" cy="457200"/>
+          </a:xfrm>
+          <a:prstGeom prst="rect">
+            <a:avLst/>
+          </a:prstGeom>
+          <a:noFill/>
+        </p:spPr>
+        <p:txBody>
+          <a:bodyPr wrap="none">
+            <a:spAutoFit/>
+          </a:bodyPr>
+          <a:lstStyle/>
+          <a:p>
+            <a:pPr algn="ctr"/>
+            <a:r>
+              <a:rPr sz="2000" b="0">
+                <a:solidFill>
+                  <a:srgbClr val="FFFF00"/>
+                </a:solidFill>
+                <a:latin typeface="微軟正黑體"/>
+              </a:rPr>
+              <a:t>《祢眼目必看顧這地》</a:t>
+            </a:r>
+          </a:p>
+        </p:txBody>
+      </p:sp>
+    </p:spTree>
+  </p:cSld>
+  <p:clrMapOvr>
+    <a:masterClrMapping/>
+  </p:clrMapOvr>
+</p:sld>
+</file>
+
+<file path=ppt/slides/slide6.xml><?xml version="1.0" encoding="utf-8"?>
+<p:sld xmlns:a="http://schemas.openxmlformats.org/drawingml/2006/main" xmlns:p="http://schemas.openxmlformats.org/presentationml/2006/main" xmlns:r="http://schemas.openxmlformats.org/officeDocument/2006/relationships">
+  <p:cSld>
+    <p:bg>
+      <p:bgPr>
+        <a:solidFill>
+          <a:srgbClr val="000000"/>
+        </a:solidFill>
+        <a:effectLst/>
+      </p:bgPr>
+    </p:bg>
+    <p:spTree>
+      <p:nvGrpSpPr>
+        <p:cNvPr id="1" name=""/>
+        <p:cNvGrpSpPr/>
+        <p:nvPr/>
+      </p:nvGrpSpPr>
+      <p:grpSpPr/>
+      <p:sp>
+        <p:nvSpPr>
+          <p:cNvPr id="2" name="TextBox 1"/>
+          <p:cNvSpPr txBox="1"/>
+          <p:nvPr/>
+        </p:nvSpPr>
+        <p:spPr>
+          <a:xfrm>
+            <a:off x="228600" y="91440"/>
+            <a:ext cx="8686800" cy="3200400"/>
+          </a:xfrm>
+          <a:prstGeom prst="rect">
+            <a:avLst/>
+          </a:prstGeom>
+          <a:noFill/>
+        </p:spPr>
+        <p:txBody>
+          <a:bodyPr wrap="square">
+            <a:spAutoFit/>
+          </a:bodyPr>
+          <a:lstStyle/>
+          <a:p>
+            <a:pPr algn="ctr"/>
+            <a:r>
+              <a:rPr sz="3200" b="1">
+                <a:solidFill>
+                  <a:srgbClr val="FFFF00"/>
+                </a:solidFill>
+                <a:latin typeface="微軟正黑體"/>
+              </a:rPr>
+              <a:t>遵行祢的旨意 謙卑回轉向祢</a:t>
+            </a:r>
+            <a:br/>
+            <a:r>
+              <a:rPr sz="3200" b="1">
+                <a:solidFill>
+                  <a:srgbClr val="FFFF00"/>
+                </a:solidFill>
+                <a:latin typeface="微軟正黑體"/>
+              </a:rPr>
+              <a:t>我們定意要跟隨祢</a:t>
+            </a:r>
+          </a:p>
+        </p:txBody>
+      </p:sp>
+      <p:sp>
+        <p:nvSpPr>
+          <p:cNvPr id="3" name="TextBox 2"/>
+          <p:cNvSpPr txBox="1"/>
+          <p:nvPr/>
+        </p:nvSpPr>
+        <p:spPr>
+          <a:xfrm>
+            <a:off x="228600" y="4572000"/>
+            <a:ext cx="8686800" cy="457200"/>
+          </a:xfrm>
+          <a:prstGeom prst="rect">
+            <a:avLst/>
+          </a:prstGeom>
+          <a:noFill/>
+        </p:spPr>
+        <p:txBody>
+          <a:bodyPr wrap="none">
+            <a:spAutoFit/>
+          </a:bodyPr>
+          <a:lstStyle/>
+          <a:p>
+            <a:pPr algn="ctr"/>
+            <a:r>
+              <a:rPr sz="2000" b="0">
+                <a:solidFill>
+                  <a:srgbClr val="FFFF00"/>
+                </a:solidFill>
+                <a:latin typeface="微軟正黑體"/>
+              </a:rPr>
+              <a:t>《祢眼目必看顧這地》</a:t>
+            </a:r>
+          </a:p>
+        </p:txBody>
+      </p:sp>
+    </p:spTree>
+  </p:cSld>
+  <p:clrMapOvr>
+    <a:masterClrMapping/>
+  </p:clrMapOvr>
+</p:sld>
+</file>
+
+<file path=ppt/slides/slide7.xml><?xml version="1.0" encoding="utf-8"?>
+<p:sld xmlns:a="http://schemas.openxmlformats.org/drawingml/2006/main" xmlns:p="http://schemas.openxmlformats.org/presentationml/2006/main" xmlns:r="http://schemas.openxmlformats.org/officeDocument/2006/relationships">
+  <p:cSld>
+    <p:bg>
+      <p:bgPr>
+        <a:solidFill>
+          <a:srgbClr val="000000"/>
+        </a:solidFill>
+        <a:effectLst/>
+      </p:bgPr>
+    </p:bg>
+    <p:spTree>
+      <p:nvGrpSpPr>
+        <p:cNvPr id="1" name=""/>
+        <p:cNvGrpSpPr/>
+        <p:nvPr/>
+      </p:nvGrpSpPr>
+      <p:grpSpPr/>
+      <p:sp>
+        <p:nvSpPr>
+          <p:cNvPr id="2" name="TextBox 1"/>
+          <p:cNvSpPr txBox="1"/>
+          <p:nvPr/>
+        </p:nvSpPr>
+        <p:spPr>
+          <a:xfrm>
+            <a:off x="228600" y="91440"/>
+            <a:ext cx="8686800" cy="3200400"/>
+          </a:xfrm>
+          <a:prstGeom prst="rect">
+            <a:avLst/>
+          </a:prstGeom>
+          <a:noFill/>
+        </p:spPr>
+        <p:txBody>
+          <a:bodyPr wrap="square">
+            <a:spAutoFit/>
+          </a:bodyPr>
+          <a:lstStyle/>
+          <a:p>
+            <a:pPr algn="ctr"/>
+            <a:r>
+              <a:rPr sz="3200" b="1">
+                <a:solidFill>
+                  <a:srgbClr val="FFFF00"/>
+                </a:solidFill>
+                <a:latin typeface="微軟正黑體"/>
+              </a:rPr>
+              <a:t>1.揚聲歡呼讚美 稱頌我的主</a:t>
+            </a:r>
+            <a:br/>
+            <a:r>
+              <a:rPr sz="3200" b="1">
+                <a:solidFill>
+                  <a:srgbClr val="FFFF00"/>
+                </a:solidFill>
+                <a:latin typeface="微軟正黑體"/>
+              </a:rPr>
+              <a:t>高聲頌揚歡唱 哈利路亞</a:t>
+            </a:r>
+          </a:p>
+        </p:txBody>
+      </p:sp>
+      <p:sp>
+        <p:nvSpPr>
+          <p:cNvPr id="3" name="TextBox 2"/>
+          <p:cNvSpPr txBox="1"/>
+          <p:nvPr/>
+        </p:nvSpPr>
+        <p:spPr>
+          <a:xfrm>
+            <a:off x="228600" y="4572000"/>
+            <a:ext cx="8686800" cy="457200"/>
+          </a:xfrm>
+          <a:prstGeom prst="rect">
+            <a:avLst/>
+          </a:prstGeom>
+          <a:noFill/>
+        </p:spPr>
+        <p:txBody>
+          <a:bodyPr wrap="none">
+            <a:spAutoFit/>
+          </a:bodyPr>
+          <a:lstStyle/>
+          <a:p>
+            <a:pPr algn="ctr"/>
+            <a:r>
+              <a:rPr sz="2000" b="0">
+                <a:solidFill>
+                  <a:srgbClr val="FFFF00"/>
+                </a:solidFill>
+                <a:latin typeface="微軟正黑體"/>
+              </a:rPr>
+              <a:t>《揚聲歡呼讚美》</a:t>
+            </a:r>
+          </a:p>
+        </p:txBody>
+      </p:sp>
+    </p:spTree>
+  </p:cSld>
+  <p:clrMapOvr>
+    <a:masterClrMapping/>
+  </p:clrMapOvr>
+</p:sld>
+</file>
+
+<file path=ppt/slides/slide8.xml><?xml version="1.0" encoding="utf-8"?>
+<p:sld xmlns:a="http://schemas.openxmlformats.org/drawingml/2006/main" xmlns:p="http://schemas.openxmlformats.org/presentationml/2006/main" xmlns:r="http://schemas.openxmlformats.org/officeDocument/2006/relationships">
+  <p:cSld>
+    <p:bg>
+      <p:bgPr>
+        <a:solidFill>
+          <a:srgbClr val="000000"/>
+        </a:solidFill>
+        <a:effectLst/>
+      </p:bgPr>
+    </p:bg>
+    <p:spTree>
+      <p:nvGrpSpPr>
+        <p:cNvPr id="1" name=""/>
+        <p:cNvGrpSpPr/>
+        <p:nvPr/>
+      </p:nvGrpSpPr>
+      <p:grpSpPr/>
+      <p:sp>
+        <p:nvSpPr>
+          <p:cNvPr id="2" name="TextBox 1"/>
+          <p:cNvSpPr txBox="1"/>
+          <p:nvPr/>
+        </p:nvSpPr>
+        <p:spPr>
+          <a:xfrm>
+            <a:off x="228600" y="91440"/>
+            <a:ext cx="8686800" cy="3200400"/>
+          </a:xfrm>
+          <a:prstGeom prst="rect">
+            <a:avLst/>
+          </a:prstGeom>
+          <a:noFill/>
+        </p:spPr>
+        <p:txBody>
+          <a:bodyPr wrap="square">
+            <a:spAutoFit/>
+          </a:bodyPr>
+          <a:lstStyle/>
+          <a:p>
+            <a:pPr algn="ctr"/>
+            <a:r>
+              <a:rPr sz="3200" b="1">
+                <a:solidFill>
+                  <a:srgbClr val="FFFF00"/>
+                </a:solidFill>
+                <a:latin typeface="微軟正黑體"/>
+              </a:rPr>
+              <a:t>來到主寶座前 尊崇讚美祂</a:t>
+            </a:r>
+            <a:br/>
+            <a:r>
+              <a:rPr sz="3200" b="1">
+                <a:solidFill>
+                  <a:srgbClr val="FFFF00"/>
+                </a:solidFill>
+                <a:latin typeface="微軟正黑體"/>
+              </a:rPr>
+              <a:t>我們歡呼喜樂 進入神的面前</a:t>
+            </a:r>
+          </a:p>
+        </p:txBody>
+      </p:sp>
+      <p:sp>
+        <p:nvSpPr>
+          <p:cNvPr id="3" name="TextBox 2"/>
+          <p:cNvSpPr txBox="1"/>
+          <p:nvPr/>
+        </p:nvSpPr>
+        <p:spPr>
+          <a:xfrm>
+            <a:off x="228600" y="4572000"/>
+            <a:ext cx="8686800" cy="457200"/>
+          </a:xfrm>
+          <a:prstGeom prst="rect">
+            <a:avLst/>
+          </a:prstGeom>
+          <a:noFill/>
+        </p:spPr>
+        <p:txBody>
+          <a:bodyPr wrap="none">
+            <a:spAutoFit/>
+          </a:bodyPr>
+          <a:lstStyle/>
+          <a:p>
+            <a:pPr algn="ctr"/>
+            <a:r>
+              <a:rPr sz="2000" b="0">
+                <a:solidFill>
+                  <a:srgbClr val="FFFF00"/>
+                </a:solidFill>
+                <a:latin typeface="微軟正黑體"/>
+              </a:rPr>
+              <a:t>《揚聲歡呼讚美》</a:t>
+            </a:r>
+          </a:p>
+        </p:txBody>
+      </p:sp>
+    </p:spTree>
+  </p:cSld>
+  <p:clrMapOvr>
+    <a:masterClrMapping/>
+  </p:clrMapOvr>
+</p:sld>
+</file>
+
+<file path=ppt/slides/slide9.xml><?xml version="1.0" encoding="utf-8"?>
+<p:sld xmlns:a="http://schemas.openxmlformats.org/drawingml/2006/main" xmlns:p="http://schemas.openxmlformats.org/presentationml/2006/main" xmlns:r="http://schemas.openxmlformats.org/officeDocument/2006/relationships">
+  <p:cSld>
+    <p:bg>
+      <p:bgPr>
+        <a:solidFill>
+          <a:srgbClr val="000000"/>
+        </a:solidFill>
+        <a:effectLst/>
+      </p:bgPr>
+    </p:bg>
+    <p:spTree>
+      <p:nvGrpSpPr>
+        <p:cNvPr id="1" name=""/>
+        <p:cNvGrpSpPr/>
+        <p:nvPr/>
+      </p:nvGrpSpPr>
+      <p:grpSpPr/>
+      <p:sp>
+        <p:nvSpPr>
+          <p:cNvPr id="2" name="TextBox 1"/>
+          <p:cNvSpPr txBox="1"/>
+          <p:nvPr/>
+        </p:nvSpPr>
+        <p:spPr>
+          <a:xfrm>
+            <a:off x="228600" y="91440"/>
+            <a:ext cx="8686800" cy="3200400"/>
+          </a:xfrm>
+          <a:prstGeom prst="rect">
+            <a:avLst/>
+          </a:prstGeom>
+          <a:noFill/>
+        </p:spPr>
+        <p:txBody>
+          <a:bodyPr wrap="square">
+            <a:spAutoFit/>
+          </a:bodyPr>
+          <a:lstStyle/>
+          <a:p>
+            <a:pPr algn="ctr"/>
+            <a:r>
+              <a:rPr sz="3200" b="1">
+                <a:solidFill>
+                  <a:srgbClr val="FFFF00"/>
+                </a:solidFill>
+                <a:latin typeface="微軟正黑體"/>
+              </a:rPr>
+              <a:t>※你是創造主 你施行拯救</a:t>
+            </a:r>
+            <a:br/>
+            <a:r>
+              <a:rPr sz="3200" b="1">
+                <a:solidFill>
+                  <a:srgbClr val="FFFF00"/>
+                </a:solidFill>
+                <a:latin typeface="微軟正黑體"/>
+              </a:rPr>
+              <a:t>你已救贖我 你是主 最大的醫生</a:t>
+            </a:r>
+          </a:p>
+        </p:txBody>
+      </p:sp>
+      <p:sp>
+        <p:nvSpPr>
+          <p:cNvPr id="3" name="TextBox 2"/>
+          <p:cNvSpPr txBox="1"/>
+          <p:nvPr/>
+        </p:nvSpPr>
+        <p:spPr>
+          <a:xfrm>
+            <a:off x="228600" y="4572000"/>
+            <a:ext cx="8686800" cy="457200"/>
+          </a:xfrm>
+          <a:prstGeom prst="rect">
+            <a:avLst/>
+          </a:prstGeom>
+          <a:noFill/>
+        </p:spPr>
+        <p:txBody>
+          <a:bodyPr wrap="none">
+            <a:spAutoFit/>
+          </a:bodyPr>
+          <a:lstStyle/>
+          <a:p>
+            <a:pPr algn="ctr"/>
+            <a:r>
+              <a:rPr sz="2000" b="0">
+                <a:solidFill>
+                  <a:srgbClr val="FFFF00"/>
+                </a:solidFill>
+                <a:latin typeface="微軟正黑體"/>
+              </a:rPr>
+              <a:t>《揚聲歡呼讚美》</a:t>
             </a:r>
           </a:p>
         </p:txBody>

</xml_diff>